<commit_message>
The owner's comments on the deck: nine wording changes
</commit_message>
<xml_diff>
--- a/CMG-Training-system-introduction.pptx
+++ b/CMG-Training-system-introduction.pptx
@@ -1505,6 +1505,10 @@
           </a:solidFill>
           <a:ln/>
         </p:spPr>
+        <p:txBody>
+          <a:bodyPr/>
+          <a:p/>
+        </p:txBody>
       </p:sp>
       <p:sp>
         <p:nvSpPr>
@@ -1527,6 +1531,10 @@
           </a:solidFill>
           <a:ln/>
         </p:spPr>
+        <p:txBody>
+          <a:bodyPr/>
+          <a:p/>
+        </p:txBody>
       </p:sp>
       <p:sp>
         <p:nvSpPr>
@@ -1665,6 +1673,10 @@
             <a:prstDash val="dash"/>
           </a:ln>
         </p:spPr>
+        <p:txBody>
+          <a:bodyPr/>
+          <a:p/>
+        </p:txBody>
       </p:sp>
       <p:sp>
         <p:nvSpPr>
@@ -2337,7 +2349,7 @@
                 <a:ea typeface="Arial" pitchFamily="34" charset="-122"/>
                 <a:cs typeface="Arial" pitchFamily="34" charset="-120"/>
               </a:rPr>
-              <a:t>Does the work fit? Which trips?</a:t>
+              <a:t>Allocating trainers to CMGs</a:t>
             </a:r>
             <a:endParaRPr lang="en-US" sz="1300" dirty="0"/>
           </a:p>
@@ -2892,7 +2904,7 @@
                 <a:ea typeface="Arial" pitchFamily="34" charset="-122"/>
                 <a:cs typeface="Arial" pitchFamily="34" charset="-120"/>
               </a:rPr>
-              <a:t>The coordinator checks it</a:t>
+              <a:t>The coordinator checks delivery reports</a:t>
             </a:r>
             <a:endParaRPr lang="en-US" sz="1300" dirty="0"/>
           </a:p>
@@ -3444,7 +3456,7 @@
                 <a:ea typeface="Arial" pitchFamily="34" charset="-122"/>
                 <a:cs typeface="Arial" pitchFamily="34" charset="-120"/>
               </a:rPr>
-              <a:t>Trainer 1, Trainer 2: not names</a:t>
+              <a:t>Trainer 1, Trainer 2: Trainer n</a:t>
             </a:r>
             <a:endParaRPr lang="en-US" sz="1200" dirty="0"/>
           </a:p>
@@ -3738,7 +3750,7 @@
                 <a:ea typeface="Arial" pitchFamily="34" charset="-122"/>
                 <a:cs typeface="Arial" pitchFamily="34" charset="-120"/>
               </a:rPr>
-              <a:t>Certified, posted there, free that day</a:t>
+              <a:t>Certified, posted there, available</a:t>
             </a:r>
             <a:endParaRPr lang="en-US" sz="1200" dirty="0"/>
           </a:p>
@@ -3922,7 +3934,7 @@
                 <a:ea typeface="Arial" pitchFamily="34" charset="-122"/>
                 <a:cs typeface="Arial" pitchFamily="34" charset="-120"/>
               </a:rPr>
-              <a:t>A draft session, when a visit has to wait</a:t>
+              <a:t>A draft session, when schedules are tentative</a:t>
             </a:r>
             <a:endParaRPr lang="en-US" sz="1500" dirty="0"/>
           </a:p>
@@ -4103,6 +4115,10 @@
           </a:solidFill>
           <a:ln/>
         </p:spPr>
+        <p:txBody>
+          <a:bodyPr/>
+          <a:p/>
+        </p:txBody>
       </p:sp>
       <p:sp>
         <p:nvSpPr>
@@ -4193,6 +4209,10 @@
             <a:prstDash val="solid"/>
           </a:ln>
         </p:spPr>
+        <p:txBody>
+          <a:bodyPr/>
+          <a:p/>
+        </p:txBody>
       </p:sp>
       <p:sp>
         <p:nvSpPr>
@@ -4213,6 +4233,10 @@
           </a:solidFill>
           <a:ln/>
         </p:spPr>
+        <p:txBody>
+          <a:bodyPr/>
+          <a:p/>
+        </p:txBody>
       </p:sp>
       <p:sp>
         <p:nvSpPr>
@@ -4277,6 +4301,10 @@
           </a:solidFill>
           <a:ln/>
         </p:spPr>
+        <p:txBody>
+          <a:bodyPr/>
+          <a:p/>
+        </p:txBody>
       </p:sp>
       <p:sp>
         <p:nvSpPr>
@@ -4385,6 +4413,10 @@
           </a:solidFill>
           <a:ln/>
         </p:spPr>
+        <p:txBody>
+          <a:bodyPr/>
+          <a:p/>
+        </p:txBody>
       </p:sp>
       <p:sp>
         <p:nvSpPr>
@@ -4449,6 +4481,10 @@
           </a:solidFill>
           <a:ln/>
         </p:spPr>
+        <p:txBody>
+          <a:bodyPr/>
+          <a:p/>
+        </p:txBody>
       </p:sp>
       <p:sp>
         <p:nvSpPr>
@@ -4560,6 +4596,10 @@
             <a:prstDash val="solid"/>
           </a:ln>
         </p:spPr>
+        <p:txBody>
+          <a:bodyPr/>
+          <a:p/>
+        </p:txBody>
       </p:sp>
       <p:sp>
         <p:nvSpPr>
@@ -4580,6 +4620,10 @@
           </a:solidFill>
           <a:ln/>
         </p:spPr>
+        <p:txBody>
+          <a:bodyPr/>
+          <a:p/>
+        </p:txBody>
       </p:sp>
       <p:sp>
         <p:nvSpPr>
@@ -4644,6 +4688,10 @@
           </a:solidFill>
           <a:ln/>
         </p:spPr>
+        <p:txBody>
+          <a:bodyPr/>
+          <a:p/>
+        </p:txBody>
       </p:sp>
       <p:sp>
         <p:nvSpPr>
@@ -4752,6 +4800,10 @@
           </a:solidFill>
           <a:ln/>
         </p:spPr>
+        <p:txBody>
+          <a:bodyPr/>
+          <a:p/>
+        </p:txBody>
       </p:sp>
       <p:sp>
         <p:nvSpPr>
@@ -4816,6 +4868,10 @@
           </a:solidFill>
           <a:ln/>
         </p:spPr>
+        <p:txBody>
+          <a:bodyPr/>
+          <a:p/>
+        </p:txBody>
       </p:sp>
       <p:sp>
         <p:nvSpPr>
@@ -4927,6 +4983,10 @@
             <a:prstDash val="solid"/>
           </a:ln>
         </p:spPr>
+        <p:txBody>
+          <a:bodyPr/>
+          <a:p/>
+        </p:txBody>
       </p:sp>
       <p:sp>
         <p:nvSpPr>
@@ -4947,6 +5007,10 @@
           </a:solidFill>
           <a:ln/>
         </p:spPr>
+        <p:txBody>
+          <a:bodyPr/>
+          <a:p/>
+        </p:txBody>
       </p:sp>
       <p:sp>
         <p:nvSpPr>
@@ -5011,6 +5075,10 @@
           </a:solidFill>
           <a:ln/>
         </p:spPr>
+        <p:txBody>
+          <a:bodyPr/>
+          <a:p/>
+        </p:txBody>
       </p:sp>
       <p:sp>
         <p:nvSpPr>
@@ -5119,6 +5187,10 @@
           </a:solidFill>
           <a:ln/>
         </p:spPr>
+        <p:txBody>
+          <a:bodyPr/>
+          <a:p/>
+        </p:txBody>
       </p:sp>
       <p:sp>
         <p:nvSpPr>
@@ -5183,6 +5255,10 @@
           </a:solidFill>
           <a:ln/>
         </p:spPr>
+        <p:txBody>
+          <a:bodyPr/>
+          <a:p/>
+        </p:txBody>
       </p:sp>
       <p:sp>
         <p:nvSpPr>
@@ -5294,6 +5370,10 @@
             <a:prstDash val="solid"/>
           </a:ln>
         </p:spPr>
+        <p:txBody>
+          <a:bodyPr/>
+          <a:p/>
+        </p:txBody>
       </p:sp>
       <p:sp>
         <p:nvSpPr>
@@ -5314,6 +5394,10 @@
           </a:solidFill>
           <a:ln/>
         </p:spPr>
+        <p:txBody>
+          <a:bodyPr/>
+          <a:p/>
+        </p:txBody>
       </p:sp>
       <p:sp>
         <p:nvSpPr>
@@ -5378,6 +5462,10 @@
           </a:solidFill>
           <a:ln/>
         </p:spPr>
+        <p:txBody>
+          <a:bodyPr/>
+          <a:p/>
+        </p:txBody>
       </p:sp>
       <p:sp>
         <p:nvSpPr>
@@ -5486,6 +5574,10 @@
           </a:solidFill>
           <a:ln/>
         </p:spPr>
+        <p:txBody>
+          <a:bodyPr/>
+          <a:p/>
+        </p:txBody>
       </p:sp>
       <p:sp>
         <p:nvSpPr>
@@ -5550,6 +5642,10 @@
           </a:solidFill>
           <a:ln/>
         </p:spPr>
+        <p:txBody>
+          <a:bodyPr/>
+          <a:p/>
+        </p:txBody>
       </p:sp>
       <p:sp>
         <p:nvSpPr>
@@ -5661,6 +5757,10 @@
             <a:prstDash val="solid"/>
           </a:ln>
         </p:spPr>
+        <p:txBody>
+          <a:bodyPr/>
+          <a:p/>
+        </p:txBody>
       </p:sp>
       <p:sp>
         <p:nvSpPr>
@@ -5681,6 +5781,10 @@
           </a:solidFill>
           <a:ln/>
         </p:spPr>
+        <p:txBody>
+          <a:bodyPr/>
+          <a:p/>
+        </p:txBody>
       </p:sp>
       <p:sp>
         <p:nvSpPr>
@@ -5745,6 +5849,10 @@
           </a:solidFill>
           <a:ln/>
         </p:spPr>
+        <p:txBody>
+          <a:bodyPr/>
+          <a:p/>
+        </p:txBody>
       </p:sp>
       <p:sp>
         <p:nvSpPr>
@@ -5853,6 +5961,10 @@
           </a:solidFill>
           <a:ln/>
         </p:spPr>
+        <p:txBody>
+          <a:bodyPr/>
+          <a:p/>
+        </p:txBody>
       </p:sp>
       <p:sp>
         <p:nvSpPr>
@@ -5917,6 +6029,10 @@
           </a:solidFill>
           <a:ln/>
         </p:spPr>
+        <p:txBody>
+          <a:bodyPr/>
+          <a:p/>
+        </p:txBody>
       </p:sp>
       <p:sp>
         <p:nvSpPr>
@@ -6027,6 +6143,10 @@
           </a:solidFill>
           <a:ln/>
         </p:spPr>
+        <p:txBody>
+          <a:bodyPr/>
+          <a:p/>
+        </p:txBody>
       </p:sp>
       <p:sp>
         <p:nvSpPr>
@@ -6050,6 +6170,10 @@
             <a:prstDash val="solid"/>
           </a:ln>
         </p:spPr>
+        <p:txBody>
+          <a:bodyPr/>
+          <a:p/>
+        </p:txBody>
       </p:sp>
       <p:sp>
         <p:nvSpPr>
@@ -6144,7 +6268,7 @@
                 <a:ea typeface="Arial" pitchFamily="34" charset="-122"/>
                 <a:cs typeface="Arial" pitchFamily="34" charset="-120"/>
               </a:rPr>
-              <a:t> It is a named set of wards inside one district, which the coordinator draws and can redraw so that one person has a workable patch. Records stay by region, district and ward.</a:t>
+              <a:t> It is a named subset of wards inside one district, which the coordinator draws and can redraw so that one person has a workable patch. Records stay by region, district and ward.</a:t>
             </a:r>
             <a:endParaRPr lang="en-US" sz="1200" dirty="0"/>
           </a:p>
@@ -9350,7 +9474,7 @@
         <p:spPr>
           <a:xfrm>
             <a:off x="825500" y="3467050"/>
-            <a:ext cx="10541000" cy="1770856"/>
+            <a:ext cx="10541000" cy="1283566"/>
           </a:xfrm>
           <a:prstGeom prst="roundRect">
             <a:avLst>
@@ -9454,7 +9578,7 @@
                 <a:ea typeface="Georgia" pitchFamily="34" charset="-122"/>
                 <a:cs typeface="Georgia" pitchFamily="34" charset="-120"/>
               </a:rPr>
-              <a:t>Choose a person, and see what circles them</a:t>
+              <a:t>Choose a person, and see their functions</a:t>
             </a:r>
             <a:endParaRPr lang="en-US" sz="2000" dirty="0"/>
           </a:p>
@@ -9462,14 +9586,14 @@
       </p:sp>
       <p:sp>
         <p:nvSpPr>
-          <p:cNvPr id="39" name="Text 29"/>
-          <p:cNvSpPr/>
-          <p:nvPr/>
-        </p:nvSpPr>
-        <p:spPr>
-          <a:xfrm>
-            <a:off x="1092200" y="4302671"/>
-            <a:ext cx="10307828" cy="471091"/>
+          <p:cNvPr id="40" name="Text 30"/>
+          <p:cNvSpPr/>
+          <p:nvPr/>
+        </p:nvSpPr>
+        <p:spPr>
+          <a:xfrm>
+            <a:off x="1092200" y="4324571"/>
+            <a:ext cx="10307828" cy="248245"/>
           </a:xfrm>
           <a:prstGeom prst="rect">
             <a:avLst/>
@@ -9490,7 +9614,7 @@
               <a:buNone/>
             </a:pPr>
             <a:r>
-              <a:rPr lang="en-US" sz="1300" dirty="0">
+              <a:rPr lang="en-US" sz="1300" b="1" dirty="0">
                 <a:solidFill>
                   <a:srgbClr val="12303D"/>
                 </a:solidFill>
@@ -9498,51 +9622,7 @@
                 <a:ea typeface="Arial" pitchFamily="34" charset="-122"/>
                 <a:cs typeface="Arial" pitchFamily="34" charset="-120"/>
               </a:rPr>
-              <a:t>The few things that matter most in their job turn round them like planets round a sun. A box beside it says what success means for them.</a:t>
-            </a:r>
-            <a:endParaRPr lang="en-US" sz="1300" dirty="0"/>
-          </a:p>
-        </p:txBody>
-      </p:sp>
-      <p:sp>
-        <p:nvSpPr>
-          <p:cNvPr id="40" name="Text 30"/>
-          <p:cNvSpPr/>
-          <p:nvPr/>
-        </p:nvSpPr>
-        <p:spPr>
-          <a:xfrm>
-            <a:off x="1092200" y="4811861"/>
-            <a:ext cx="10307828" cy="248245"/>
-          </a:xfrm>
-          <a:prstGeom prst="rect">
-            <a:avLst/>
-          </a:prstGeom>
-          <a:noFill/>
-          <a:ln/>
-        </p:spPr>
-        <p:txBody>
-          <a:bodyPr wrap="square" lIns="0" tIns="0" rIns="0" bIns="0" rtlCol="0" anchor="t">
-            <a:normAutofit/>
-          </a:bodyPr>
-          <a:lstStyle/>
-          <a:p>
-            <a:pPr algn="l" indent="0" marL="0">
-              <a:lnSpc>
-                <a:spcPts val="1755"/>
-              </a:lnSpc>
-              <a:buNone/>
-            </a:pPr>
-            <a:r>
-              <a:rPr lang="en-US" sz="1300" b="1" dirty="0">
-                <a:solidFill>
-                  <a:srgbClr val="12303D"/>
-                </a:solidFill>
-                <a:latin typeface="Arial" pitchFamily="34" charset="0"/>
-                <a:ea typeface="Arial" pitchFamily="34" charset="-122"/>
-                <a:cs typeface="Arial" pitchFamily="34" charset="-120"/>
-              </a:rPr>
-              <a:t>Open it:</a:t>
+              <a:t>Click link to see visual representation of personas:</a:t>
             </a:r>
             <a:r>
               <a:rPr lang="en-US" sz="1300" dirty="0">

</xml_diff>

<commit_message>
Slide 2 overlap cleared, slide 4 spaced from its title, slide 6 wording
</commit_message>
<xml_diff>
--- a/CMG-Training-system-introduction.pptx
+++ b/CMG-Training-system-introduction.pptx
@@ -1655,7 +1655,7 @@
         </p:nvSpPr>
         <p:spPr>
           <a:xfrm>
-            <a:off x="822325" y="1730375"/>
+            <a:off x="502285" y="1730375"/>
             <a:ext cx="2800350" cy="3079750"/>
           </a:xfrm>
           <a:prstGeom prst="roundRect">
@@ -1686,7 +1686,7 @@
         </p:nvSpPr>
         <p:spPr>
           <a:xfrm>
-            <a:off x="1009650" y="1905000"/>
+            <a:off x="689610" y="1905000"/>
             <a:ext cx="2498471" cy="208409"/>
           </a:xfrm>
           <a:prstGeom prst="rect">
@@ -1730,7 +1730,7 @@
         </p:nvSpPr>
         <p:spPr>
           <a:xfrm>
-            <a:off x="1009650" y="2164209"/>
+            <a:off x="689610" y="2164209"/>
             <a:ext cx="2498471" cy="469850"/>
           </a:xfrm>
           <a:prstGeom prst="rect">
@@ -1781,7 +1781,7 @@
         </p:blipFill>
         <p:spPr>
           <a:xfrm>
-            <a:off x="1009650" y="2667695"/>
+            <a:off x="689610" y="2667695"/>
             <a:ext cx="241300" cy="241300"/>
           </a:xfrm>
           <a:prstGeom prst="rect">
@@ -1797,7 +1797,7 @@
         </p:nvSpPr>
         <p:spPr>
           <a:xfrm>
-            <a:off x="1339850" y="2689275"/>
+            <a:off x="1019810" y="2689275"/>
             <a:ext cx="1662906" cy="223490"/>
           </a:xfrm>
           <a:prstGeom prst="rect">
@@ -1859,7 +1859,7 @@
         </p:blipFill>
         <p:spPr>
           <a:xfrm>
-            <a:off x="1009650" y="3017292"/>
+            <a:off x="689610" y="3017292"/>
             <a:ext cx="200422" cy="241300"/>
           </a:xfrm>
           <a:prstGeom prst="rect">
@@ -1875,7 +1875,7 @@
         </p:nvSpPr>
         <p:spPr>
           <a:xfrm>
-            <a:off x="1298972" y="2939852"/>
+            <a:off x="978932" y="2939852"/>
             <a:ext cx="2200469" cy="421580"/>
           </a:xfrm>
           <a:prstGeom prst="rect">
@@ -1937,7 +1937,7 @@
         </p:blipFill>
         <p:spPr>
           <a:xfrm>
-            <a:off x="1009650" y="3366889"/>
+            <a:off x="689610" y="3366889"/>
             <a:ext cx="241300" cy="241300"/>
           </a:xfrm>
           <a:prstGeom prst="rect">
@@ -1953,7 +1953,7 @@
         </p:nvSpPr>
         <p:spPr>
           <a:xfrm>
-            <a:off x="1339850" y="3388469"/>
+            <a:off x="1019810" y="3388469"/>
             <a:ext cx="1610767" cy="223490"/>
           </a:xfrm>
           <a:prstGeom prst="rect">
@@ -2015,7 +2015,7 @@
         </p:blipFill>
         <p:spPr>
           <a:xfrm>
-            <a:off x="1009650" y="3716486"/>
+            <a:off x="689610" y="3716486"/>
             <a:ext cx="214908" cy="241300"/>
           </a:xfrm>
           <a:prstGeom prst="rect">
@@ -2031,7 +2031,7 @@
         </p:nvSpPr>
         <p:spPr>
           <a:xfrm>
-            <a:off x="1313458" y="3639046"/>
+            <a:off x="993418" y="3639046"/>
             <a:ext cx="2185549" cy="421580"/>
           </a:xfrm>
           <a:prstGeom prst="rect">
@@ -2086,7 +2086,7 @@
         </p:nvSpPr>
         <p:spPr>
           <a:xfrm>
-            <a:off x="1009650" y="4083248"/>
+            <a:off x="689610" y="4083248"/>
             <a:ext cx="2498471" cy="577652"/>
           </a:xfrm>
           <a:prstGeom prst="rect">
@@ -4179,7 +4179,7 @@
         </p:blipFill>
         <p:spPr>
           <a:xfrm>
-            <a:off x="812800" y="1361430"/>
+            <a:off x="812800" y="1635750"/>
             <a:ext cx="10566400" cy="304800"/>
           </a:xfrm>
           <a:prstGeom prst="rect">
@@ -4195,7 +4195,7 @@
         </p:nvSpPr>
         <p:spPr>
           <a:xfrm>
-            <a:off x="825500" y="1678930"/>
+            <a:off x="825500" y="1953250"/>
             <a:ext cx="10541000" cy="2911475"/>
           </a:xfrm>
           <a:prstGeom prst="rect">
@@ -4222,7 +4222,7 @@
         </p:nvSpPr>
         <p:spPr>
           <a:xfrm>
-            <a:off x="838200" y="1691630"/>
+            <a:off x="838200" y="1965950"/>
             <a:ext cx="1143000" cy="523875"/>
           </a:xfrm>
           <a:prstGeom prst="rect">
@@ -4246,7 +4246,7 @@
         </p:nvSpPr>
         <p:spPr>
           <a:xfrm>
-            <a:off x="812800" y="1742430"/>
+            <a:off x="812800" y="2016750"/>
             <a:ext cx="1193800" cy="447675"/>
           </a:xfrm>
           <a:prstGeom prst="rect">
@@ -4290,7 +4290,7 @@
         </p:nvSpPr>
         <p:spPr>
           <a:xfrm>
-            <a:off x="1981200" y="1691630"/>
+            <a:off x="1981200" y="1965950"/>
             <a:ext cx="3352800" cy="523875"/>
           </a:xfrm>
           <a:prstGeom prst="rect">
@@ -4314,7 +4314,7 @@
         </p:nvSpPr>
         <p:spPr>
           <a:xfrm>
-            <a:off x="2133600" y="1742430"/>
+            <a:off x="2133600" y="2016750"/>
             <a:ext cx="3139440" cy="244475"/>
           </a:xfrm>
           <a:prstGeom prst="rect">
@@ -4358,7 +4358,7 @@
         </p:nvSpPr>
         <p:spPr>
           <a:xfrm>
-            <a:off x="2133600" y="1974205"/>
+            <a:off x="2133600" y="2248525"/>
             <a:ext cx="3139440" cy="215900"/>
           </a:xfrm>
           <a:prstGeom prst="rect">
@@ -4402,7 +4402,7 @@
         </p:nvSpPr>
         <p:spPr>
           <a:xfrm>
-            <a:off x="5334000" y="1691630"/>
+            <a:off x="5334000" y="1965950"/>
             <a:ext cx="2667000" cy="523875"/>
           </a:xfrm>
           <a:prstGeom prst="rect">
@@ -4426,7 +4426,7 @@
         </p:nvSpPr>
         <p:spPr>
           <a:xfrm>
-            <a:off x="5411724" y="1742430"/>
+            <a:off x="5411724" y="2016750"/>
             <a:ext cx="2511552" cy="447675"/>
           </a:xfrm>
           <a:prstGeom prst="rect">
@@ -4470,7 +4470,7 @@
         </p:nvSpPr>
         <p:spPr>
           <a:xfrm>
-            <a:off x="8001000" y="1691630"/>
+            <a:off x="8001000" y="1965950"/>
             <a:ext cx="3352800" cy="523875"/>
           </a:xfrm>
           <a:prstGeom prst="rect">
@@ -4494,7 +4494,7 @@
         </p:nvSpPr>
         <p:spPr>
           <a:xfrm>
-            <a:off x="8153400" y="1742430"/>
+            <a:off x="8153400" y="2016750"/>
             <a:ext cx="3139440" cy="244475"/>
           </a:xfrm>
           <a:prstGeom prst="rect">
@@ -4538,7 +4538,7 @@
         </p:nvSpPr>
         <p:spPr>
           <a:xfrm>
-            <a:off x="8153400" y="1974205"/>
+            <a:off x="8153400" y="2248525"/>
             <a:ext cx="3139440" cy="215900"/>
           </a:xfrm>
           <a:prstGeom prst="rect">
@@ -4582,7 +4582,7 @@
         </p:nvSpPr>
         <p:spPr>
           <a:xfrm>
-            <a:off x="838200" y="2225030"/>
+            <a:off x="838200" y="2499350"/>
             <a:ext cx="10515600" cy="0"/>
           </a:xfrm>
           <a:prstGeom prst="line">
@@ -4609,7 +4609,7 @@
         </p:nvSpPr>
         <p:spPr>
           <a:xfrm>
-            <a:off x="838200" y="2234555"/>
+            <a:off x="838200" y="2508875"/>
             <a:ext cx="1143000" cy="523875"/>
           </a:xfrm>
           <a:prstGeom prst="rect">
@@ -4633,7 +4633,7 @@
         </p:nvSpPr>
         <p:spPr>
           <a:xfrm>
-            <a:off x="812800" y="2285355"/>
+            <a:off x="812800" y="2559675"/>
             <a:ext cx="1193800" cy="447675"/>
           </a:xfrm>
           <a:prstGeom prst="rect">
@@ -4677,7 +4677,7 @@
         </p:nvSpPr>
         <p:spPr>
           <a:xfrm>
-            <a:off x="1981200" y="2234555"/>
+            <a:off x="1981200" y="2508875"/>
             <a:ext cx="3352800" cy="523875"/>
           </a:xfrm>
           <a:prstGeom prst="rect">
@@ -4701,7 +4701,7 @@
         </p:nvSpPr>
         <p:spPr>
           <a:xfrm>
-            <a:off x="2133600" y="2285355"/>
+            <a:off x="2133600" y="2559675"/>
             <a:ext cx="3139440" cy="244475"/>
           </a:xfrm>
           <a:prstGeom prst="rect">
@@ -4745,7 +4745,7 @@
         </p:nvSpPr>
         <p:spPr>
           <a:xfrm>
-            <a:off x="2133600" y="2517130"/>
+            <a:off x="2133600" y="2791450"/>
             <a:ext cx="3139440" cy="215900"/>
           </a:xfrm>
           <a:prstGeom prst="rect">
@@ -4789,7 +4789,7 @@
         </p:nvSpPr>
         <p:spPr>
           <a:xfrm>
-            <a:off x="5334000" y="2234555"/>
+            <a:off x="5334000" y="2508875"/>
             <a:ext cx="2667000" cy="523875"/>
           </a:xfrm>
           <a:prstGeom prst="rect">
@@ -4813,7 +4813,7 @@
         </p:nvSpPr>
         <p:spPr>
           <a:xfrm>
-            <a:off x="5411724" y="2285355"/>
+            <a:off x="5411724" y="2559675"/>
             <a:ext cx="2511552" cy="447675"/>
           </a:xfrm>
           <a:prstGeom prst="rect">
@@ -4857,7 +4857,7 @@
         </p:nvSpPr>
         <p:spPr>
           <a:xfrm>
-            <a:off x="8001000" y="2234555"/>
+            <a:off x="8001000" y="2508875"/>
             <a:ext cx="3352800" cy="523875"/>
           </a:xfrm>
           <a:prstGeom prst="rect">
@@ -4881,7 +4881,7 @@
         </p:nvSpPr>
         <p:spPr>
           <a:xfrm>
-            <a:off x="8153400" y="2285355"/>
+            <a:off x="8153400" y="2559675"/>
             <a:ext cx="3139440" cy="244475"/>
           </a:xfrm>
           <a:prstGeom prst="rect">
@@ -4925,7 +4925,7 @@
         </p:nvSpPr>
         <p:spPr>
           <a:xfrm>
-            <a:off x="8153400" y="2517130"/>
+            <a:off x="8153400" y="2791450"/>
             <a:ext cx="3139440" cy="215900"/>
           </a:xfrm>
           <a:prstGeom prst="rect">
@@ -4969,7 +4969,7 @@
         </p:nvSpPr>
         <p:spPr>
           <a:xfrm>
-            <a:off x="838200" y="2767955"/>
+            <a:off x="838200" y="3042275"/>
             <a:ext cx="10515600" cy="0"/>
           </a:xfrm>
           <a:prstGeom prst="line">
@@ -4996,7 +4996,7 @@
         </p:nvSpPr>
         <p:spPr>
           <a:xfrm>
-            <a:off x="838200" y="2777480"/>
+            <a:off x="838200" y="3051800"/>
             <a:ext cx="1143000" cy="714375"/>
           </a:xfrm>
           <a:prstGeom prst="rect">
@@ -5020,7 +5020,7 @@
         </p:nvSpPr>
         <p:spPr>
           <a:xfrm>
-            <a:off x="812800" y="2828280"/>
+            <a:off x="812800" y="3102600"/>
             <a:ext cx="1193800" cy="638175"/>
           </a:xfrm>
           <a:prstGeom prst="rect">
@@ -5064,7 +5064,7 @@
         </p:nvSpPr>
         <p:spPr>
           <a:xfrm>
-            <a:off x="1981200" y="2777480"/>
+            <a:off x="1981200" y="3051800"/>
             <a:ext cx="3352800" cy="714375"/>
           </a:xfrm>
           <a:prstGeom prst="rect">
@@ -5088,7 +5088,7 @@
         </p:nvSpPr>
         <p:spPr>
           <a:xfrm>
-            <a:off x="2133600" y="2828280"/>
+            <a:off x="2133600" y="3102600"/>
             <a:ext cx="3139440" cy="244475"/>
           </a:xfrm>
           <a:prstGeom prst="rect">
@@ -5132,7 +5132,7 @@
         </p:nvSpPr>
         <p:spPr>
           <a:xfrm>
-            <a:off x="2133600" y="3060055"/>
+            <a:off x="2133600" y="3334375"/>
             <a:ext cx="3139440" cy="406400"/>
           </a:xfrm>
           <a:prstGeom prst="rect">
@@ -5176,7 +5176,7 @@
         </p:nvSpPr>
         <p:spPr>
           <a:xfrm>
-            <a:off x="5334000" y="2777480"/>
+            <a:off x="5334000" y="3051800"/>
             <a:ext cx="2667000" cy="714375"/>
           </a:xfrm>
           <a:prstGeom prst="rect">
@@ -5200,7 +5200,7 @@
         </p:nvSpPr>
         <p:spPr>
           <a:xfrm>
-            <a:off x="5411724" y="2828280"/>
+            <a:off x="5411724" y="3102600"/>
             <a:ext cx="2511552" cy="638175"/>
           </a:xfrm>
           <a:prstGeom prst="rect">
@@ -5244,7 +5244,7 @@
         </p:nvSpPr>
         <p:spPr>
           <a:xfrm>
-            <a:off x="8001000" y="2777480"/>
+            <a:off x="8001000" y="3051800"/>
             <a:ext cx="3352800" cy="714375"/>
           </a:xfrm>
           <a:prstGeom prst="rect">
@@ -5268,7 +5268,7 @@
         </p:nvSpPr>
         <p:spPr>
           <a:xfrm>
-            <a:off x="8153400" y="2923530"/>
+            <a:off x="8153400" y="3197850"/>
             <a:ext cx="3139440" cy="244475"/>
           </a:xfrm>
           <a:prstGeom prst="rect">
@@ -5312,7 +5312,7 @@
         </p:nvSpPr>
         <p:spPr>
           <a:xfrm>
-            <a:off x="8153400" y="3155305"/>
+            <a:off x="8153400" y="3429625"/>
             <a:ext cx="3139440" cy="215900"/>
           </a:xfrm>
           <a:prstGeom prst="rect">
@@ -5356,7 +5356,7 @@
         </p:nvSpPr>
         <p:spPr>
           <a:xfrm>
-            <a:off x="838200" y="3501380"/>
+            <a:off x="838200" y="3775700"/>
             <a:ext cx="10515600" cy="0"/>
           </a:xfrm>
           <a:prstGeom prst="line">
@@ -5383,7 +5383,7 @@
         </p:nvSpPr>
         <p:spPr>
           <a:xfrm>
-            <a:off x="838200" y="3510905"/>
+            <a:off x="838200" y="3785225"/>
             <a:ext cx="1143000" cy="523875"/>
           </a:xfrm>
           <a:prstGeom prst="rect">
@@ -5407,7 +5407,7 @@
         </p:nvSpPr>
         <p:spPr>
           <a:xfrm>
-            <a:off x="812800" y="3561705"/>
+            <a:off x="812800" y="3836025"/>
             <a:ext cx="1193800" cy="447675"/>
           </a:xfrm>
           <a:prstGeom prst="rect">
@@ -5451,7 +5451,7 @@
         </p:nvSpPr>
         <p:spPr>
           <a:xfrm>
-            <a:off x="1981200" y="3510905"/>
+            <a:off x="1981200" y="3785225"/>
             <a:ext cx="3352800" cy="523875"/>
           </a:xfrm>
           <a:prstGeom prst="rect">
@@ -5475,7 +5475,7 @@
         </p:nvSpPr>
         <p:spPr>
           <a:xfrm>
-            <a:off x="2133600" y="3561705"/>
+            <a:off x="2133600" y="3836025"/>
             <a:ext cx="3139440" cy="244475"/>
           </a:xfrm>
           <a:prstGeom prst="rect">
@@ -5519,7 +5519,7 @@
         </p:nvSpPr>
         <p:spPr>
           <a:xfrm>
-            <a:off x="2133600" y="3793480"/>
+            <a:off x="2133600" y="4067800"/>
             <a:ext cx="3139440" cy="215900"/>
           </a:xfrm>
           <a:prstGeom prst="rect">
@@ -5563,7 +5563,7 @@
         </p:nvSpPr>
         <p:spPr>
           <a:xfrm>
-            <a:off x="5334000" y="3510905"/>
+            <a:off x="5334000" y="3785225"/>
             <a:ext cx="2667000" cy="523875"/>
           </a:xfrm>
           <a:prstGeom prst="rect">
@@ -5587,7 +5587,7 @@
         </p:nvSpPr>
         <p:spPr>
           <a:xfrm>
-            <a:off x="5411724" y="3561705"/>
+            <a:off x="5411724" y="3836025"/>
             <a:ext cx="2511552" cy="447675"/>
           </a:xfrm>
           <a:prstGeom prst="rect">
@@ -5631,7 +5631,7 @@
         </p:nvSpPr>
         <p:spPr>
           <a:xfrm>
-            <a:off x="8001000" y="3510905"/>
+            <a:off x="8001000" y="3785225"/>
             <a:ext cx="3352800" cy="523875"/>
           </a:xfrm>
           <a:prstGeom prst="rect">
@@ -5655,7 +5655,7 @@
         </p:nvSpPr>
         <p:spPr>
           <a:xfrm>
-            <a:off x="8153400" y="3561705"/>
+            <a:off x="8153400" y="3836025"/>
             <a:ext cx="3139440" cy="244475"/>
           </a:xfrm>
           <a:prstGeom prst="rect">
@@ -5699,7 +5699,7 @@
         </p:nvSpPr>
         <p:spPr>
           <a:xfrm>
-            <a:off x="8153400" y="3793480"/>
+            <a:off x="8153400" y="4067800"/>
             <a:ext cx="3139440" cy="215900"/>
           </a:xfrm>
           <a:prstGeom prst="rect">
@@ -5743,7 +5743,7 @@
         </p:nvSpPr>
         <p:spPr>
           <a:xfrm>
-            <a:off x="838200" y="4044305"/>
+            <a:off x="838200" y="4318625"/>
             <a:ext cx="10515600" cy="0"/>
           </a:xfrm>
           <a:prstGeom prst="line">
@@ -5770,7 +5770,7 @@
         </p:nvSpPr>
         <p:spPr>
           <a:xfrm>
-            <a:off x="838200" y="4053830"/>
+            <a:off x="838200" y="4328150"/>
             <a:ext cx="1143000" cy="523875"/>
           </a:xfrm>
           <a:prstGeom prst="rect">
@@ -5794,7 +5794,7 @@
         </p:nvSpPr>
         <p:spPr>
           <a:xfrm>
-            <a:off x="812800" y="4104630"/>
+            <a:off x="812800" y="4378950"/>
             <a:ext cx="1193800" cy="447675"/>
           </a:xfrm>
           <a:prstGeom prst="rect">
@@ -5838,7 +5838,7 @@
         </p:nvSpPr>
         <p:spPr>
           <a:xfrm>
-            <a:off x="1981200" y="4053830"/>
+            <a:off x="1981200" y="4328150"/>
             <a:ext cx="3352800" cy="523875"/>
           </a:xfrm>
           <a:prstGeom prst="rect">
@@ -5862,7 +5862,7 @@
         </p:nvSpPr>
         <p:spPr>
           <a:xfrm>
-            <a:off x="2133600" y="4104630"/>
+            <a:off x="2133600" y="4378950"/>
             <a:ext cx="3139440" cy="244475"/>
           </a:xfrm>
           <a:prstGeom prst="rect">
@@ -5906,7 +5906,7 @@
         </p:nvSpPr>
         <p:spPr>
           <a:xfrm>
-            <a:off x="2133600" y="4336405"/>
+            <a:off x="2133600" y="4610725"/>
             <a:ext cx="3139440" cy="215900"/>
           </a:xfrm>
           <a:prstGeom prst="rect">
@@ -5950,7 +5950,7 @@
         </p:nvSpPr>
         <p:spPr>
           <a:xfrm>
-            <a:off x="5334000" y="4053830"/>
+            <a:off x="5334000" y="4328150"/>
             <a:ext cx="2667000" cy="523875"/>
           </a:xfrm>
           <a:prstGeom prst="rect">
@@ -5974,7 +5974,7 @@
         </p:nvSpPr>
         <p:spPr>
           <a:xfrm>
-            <a:off x="5411724" y="4104630"/>
+            <a:off x="5411724" y="4378950"/>
             <a:ext cx="2511552" cy="447675"/>
           </a:xfrm>
           <a:prstGeom prst="rect">
@@ -6018,7 +6018,7 @@
         </p:nvSpPr>
         <p:spPr>
           <a:xfrm>
-            <a:off x="8001000" y="4053830"/>
+            <a:off x="8001000" y="4328150"/>
             <a:ext cx="3352800" cy="523875"/>
           </a:xfrm>
           <a:prstGeom prst="rect">
@@ -6042,7 +6042,7 @@
         </p:nvSpPr>
         <p:spPr>
           <a:xfrm>
-            <a:off x="8153400" y="4104630"/>
+            <a:off x="8153400" y="4378950"/>
             <a:ext cx="3139440" cy="244475"/>
           </a:xfrm>
           <a:prstGeom prst="rect">
@@ -6086,7 +6086,7 @@
         </p:nvSpPr>
         <p:spPr>
           <a:xfrm>
-            <a:off x="8153400" y="4336405"/>
+            <a:off x="8153400" y="4610725"/>
             <a:ext cx="3139440" cy="215900"/>
           </a:xfrm>
           <a:prstGeom prst="rect">
@@ -6130,7 +6130,7 @@
         </p:nvSpPr>
         <p:spPr>
           <a:xfrm>
-            <a:off x="812800" y="4704705"/>
+            <a:off x="812800" y="4979025"/>
             <a:ext cx="10566400" cy="523180"/>
           </a:xfrm>
           <a:prstGeom prst="roundRect">
@@ -6156,7 +6156,7 @@
         </p:nvSpPr>
         <p:spPr>
           <a:xfrm>
-            <a:off x="844550" y="4704705"/>
+            <a:off x="844550" y="4979025"/>
             <a:ext cx="0" cy="523180"/>
           </a:xfrm>
           <a:prstGeom prst="line">
@@ -6183,7 +6183,7 @@
         </p:nvSpPr>
         <p:spPr>
           <a:xfrm>
-            <a:off x="1028700" y="4859635"/>
+            <a:off x="1028700" y="5133955"/>
             <a:ext cx="533450" cy="238720"/>
           </a:xfrm>
           <a:prstGeom prst="rect">
@@ -6227,7 +6227,7 @@
         </p:nvSpPr>
         <p:spPr>
           <a:xfrm>
-            <a:off x="1638350" y="4768205"/>
+            <a:off x="1638350" y="5042525"/>
             <a:ext cx="9876104" cy="421580"/>
           </a:xfrm>
           <a:prstGeom prst="rect">
@@ -6282,7 +6282,7 @@
         </p:nvSpPr>
         <p:spPr>
           <a:xfrm>
-            <a:off x="812800" y="6238280"/>
+            <a:off x="812800" y="6512600"/>
             <a:ext cx="10883392" cy="238720"/>
           </a:xfrm>
           <a:prstGeom prst="rect">
@@ -8500,7 +8500,7 @@
                 <a:ea typeface="Arial" pitchFamily="34" charset="-122"/>
                 <a:cs typeface="Arial" pitchFamily="34" charset="-120"/>
               </a:rPr>
-              <a:t>Eight people carry a lesson from an author's desk to a village meeting and back. They stand here in the order the work reaches them.</a:t>
+              <a:t>Eight people help deliver a lesson from a training content author's desk to a village meeting and back. The roles are listed here.</a:t>
             </a:r>
             <a:endParaRPr lang="en-US" sz="1500" dirty="0"/>
           </a:p>
@@ -9474,7 +9474,7 @@
         <p:spPr>
           <a:xfrm>
             <a:off x="825500" y="3467050"/>
-            <a:ext cx="10541000" cy="1283566"/>
+            <a:ext cx="10541000" cy="1004713"/>
           </a:xfrm>
           <a:prstGeom prst="roundRect">
             <a:avLst>
@@ -9498,57 +9498,13 @@
       </p:sp>
       <p:sp>
         <p:nvSpPr>
-          <p:cNvPr id="37" name="Text 27"/>
-          <p:cNvSpPr/>
-          <p:nvPr/>
-        </p:nvSpPr>
-        <p:spPr>
-          <a:xfrm>
-            <a:off x="1092200" y="3670250"/>
-            <a:ext cx="10307828" cy="238720"/>
-          </a:xfrm>
-          <a:prstGeom prst="rect">
-            <a:avLst/>
-          </a:prstGeom>
-          <a:noFill/>
-          <a:ln/>
-        </p:spPr>
-        <p:txBody>
-          <a:bodyPr wrap="square" lIns="0" tIns="0" rIns="0" bIns="0" rtlCol="0" anchor="t">
-            <a:normAutofit/>
-          </a:bodyPr>
-          <a:lstStyle/>
-          <a:p>
-            <a:pPr algn="l" indent="0" marL="0">
-              <a:lnSpc>
-                <a:spcPts val="1680"/>
-              </a:lnSpc>
-              <a:buNone/>
-            </a:pPr>
-            <a:r>
-              <a:rPr lang="en-US" sz="1200" b="1" spc="150" kern="0" dirty="0">
-                <a:solidFill>
-                  <a:srgbClr val="12435A"/>
-                </a:solidFill>
-                <a:latin typeface="Arial" pitchFamily="34" charset="0"/>
-                <a:ea typeface="Arial" pitchFamily="34" charset="-122"/>
-                <a:cs typeface="Arial" pitchFamily="34" charset="-120"/>
-              </a:rPr>
-              <a:t>ON THE LINKED PAGE</a:t>
-            </a:r>
-            <a:endParaRPr lang="en-US" sz="1200" dirty="0"/>
-          </a:p>
-        </p:txBody>
-      </p:sp>
-      <p:sp>
-        <p:nvSpPr>
           <p:cNvPr id="38" name="Text 28"/>
           <p:cNvSpPr/>
           <p:nvPr/>
         </p:nvSpPr>
         <p:spPr>
           <a:xfrm>
-            <a:off x="1092200" y="3947071"/>
+            <a:off x="1092200" y="3668218"/>
             <a:ext cx="10307828" cy="317500"/>
           </a:xfrm>
           <a:prstGeom prst="rect">
@@ -9592,7 +9548,7 @@
         </p:nvSpPr>
         <p:spPr>
           <a:xfrm>
-            <a:off x="1092200" y="4324571"/>
+            <a:off x="1092200" y="4045718"/>
             <a:ext cx="10307828" cy="248245"/>
           </a:xfrm>
           <a:prstGeom prst="rect">
@@ -9622,7 +9578,7 @@
                 <a:ea typeface="Arial" pitchFamily="34" charset="-122"/>
                 <a:cs typeface="Arial" pitchFamily="34" charset="-120"/>
               </a:rPr>
-              <a:t>Click link to see visual representation of personas:</a:t>
+              <a:t>Click link to see visual representation:</a:t>
             </a:r>
             <a:r>
               <a:rPr lang="en-US" sz="1300" dirty="0">

</xml_diff>

<commit_message>
Slide 5 wording, slide 6 wording and tidied link, fonts renamed to the agreed Domine/Nunito Sans throughout
</commit_message>
<xml_diff>
--- a/CMG-Training-system-introduction.pptx
+++ b/CMG-Training-system-introduction.pptx
@@ -1354,7 +1354,7 @@
                 <a:solidFill>
                   <a:srgbClr val="E9B48F"/>
                 </a:solidFill>
-                <a:latin typeface="Arial" pitchFamily="34" charset="0"/>
+                <a:latin typeface="Nunito Sans" pitchFamily="34" charset="0"/>
                 <a:ea typeface="Arial" pitchFamily="34" charset="-122"/>
                 <a:cs typeface="Arial" pitchFamily="34" charset="-120"/>
               </a:rPr>
@@ -1398,7 +1398,7 @@
                 <a:solidFill>
                   <a:srgbClr val="FFFBF5"/>
                 </a:solidFill>
-                <a:latin typeface="Georgia" pitchFamily="34" charset="0"/>
+                <a:latin typeface="Domine" pitchFamily="34" charset="0"/>
                 <a:ea typeface="Georgia" pitchFamily="34" charset="-122"/>
                 <a:cs typeface="Georgia" pitchFamily="34" charset="-120"/>
               </a:rPr>
@@ -1442,7 +1442,7 @@
                 <a:solidFill>
                   <a:srgbClr val="BFD8D5"/>
                 </a:solidFill>
-                <a:latin typeface="Arial" pitchFamily="34" charset="0"/>
+                <a:latin typeface="Nunito Sans" pitchFamily="34" charset="0"/>
                 <a:ea typeface="Arial" pitchFamily="34" charset="-122"/>
                 <a:cs typeface="Arial" pitchFamily="34" charset="-120"/>
               </a:rPr>
@@ -1570,7 +1570,7 @@
                 <a:solidFill>
                   <a:srgbClr val="4F6B3A"/>
                 </a:solidFill>
-                <a:latin typeface="Arial" pitchFamily="34" charset="0"/>
+                <a:latin typeface="Nunito Sans" pitchFamily="34" charset="0"/>
                 <a:ea typeface="Arial" pitchFamily="34" charset="-122"/>
                 <a:cs typeface="Arial" pitchFamily="34" charset="-120"/>
               </a:rPr>
@@ -1637,7 +1637,7 @@
                 <a:solidFill>
                   <a:srgbClr val="12303D"/>
                 </a:solidFill>
-                <a:latin typeface="Georgia" pitchFamily="34" charset="0"/>
+                <a:latin typeface="Domine" pitchFamily="34" charset="0"/>
                 <a:ea typeface="Georgia" pitchFamily="34" charset="-122"/>
                 <a:cs typeface="Georgia" pitchFamily="34" charset="-120"/>
               </a:rPr>
@@ -1712,7 +1712,7 @@
                 <a:solidFill>
                   <a:srgbClr val="12435A"/>
                 </a:solidFill>
-                <a:latin typeface="Arial" pitchFamily="34" charset="0"/>
+                <a:latin typeface="Nunito Sans" pitchFamily="34" charset="0"/>
                 <a:ea typeface="Arial" pitchFamily="34" charset="-122"/>
                 <a:cs typeface="Arial" pitchFamily="34" charset="-120"/>
               </a:rPr>
@@ -1756,7 +1756,7 @@
                 <a:solidFill>
                   <a:srgbClr val="12303D"/>
                 </a:solidFill>
-                <a:latin typeface="Georgia" pitchFamily="34" charset="0"/>
+                <a:latin typeface="Domine" pitchFamily="34" charset="0"/>
                 <a:ea typeface="Georgia" pitchFamily="34" charset="-122"/>
                 <a:cs typeface="Georgia" pitchFamily="34" charset="-120"/>
               </a:rPr>
@@ -1823,7 +1823,7 @@
                 <a:solidFill>
                   <a:srgbClr val="12303D"/>
                 </a:solidFill>
-                <a:latin typeface="Arial" pitchFamily="34" charset="0"/>
+                <a:latin typeface="Nunito Sans" pitchFamily="34" charset="0"/>
                 <a:ea typeface="Arial" pitchFamily="34" charset="-122"/>
                 <a:cs typeface="Arial" pitchFamily="34" charset="-120"/>
               </a:rPr>
@@ -1834,7 +1834,7 @@
                 <a:solidFill>
                   <a:srgbClr val="12303D"/>
                 </a:solidFill>
-                <a:latin typeface="Arial" pitchFamily="34" charset="0"/>
+                <a:latin typeface="Nunito Sans" pitchFamily="34" charset="0"/>
                 <a:ea typeface="Arial" pitchFamily="34" charset="-122"/>
                 <a:cs typeface="Arial" pitchFamily="34" charset="-120"/>
               </a:rPr>
@@ -1901,7 +1901,7 @@
                 <a:solidFill>
                   <a:srgbClr val="12303D"/>
                 </a:solidFill>
-                <a:latin typeface="Arial" pitchFamily="34" charset="0"/>
+                <a:latin typeface="Nunito Sans" pitchFamily="34" charset="0"/>
                 <a:ea typeface="Arial" pitchFamily="34" charset="-122"/>
                 <a:cs typeface="Arial" pitchFamily="34" charset="-120"/>
               </a:rPr>
@@ -1912,7 +1912,7 @@
                 <a:solidFill>
                   <a:srgbClr val="12303D"/>
                 </a:solidFill>
-                <a:latin typeface="Arial" pitchFamily="34" charset="0"/>
+                <a:latin typeface="Nunito Sans" pitchFamily="34" charset="0"/>
                 <a:ea typeface="Arial" pitchFamily="34" charset="-122"/>
                 <a:cs typeface="Arial" pitchFamily="34" charset="-120"/>
               </a:rPr>
@@ -1979,7 +1979,7 @@
                 <a:solidFill>
                   <a:srgbClr val="12303D"/>
                 </a:solidFill>
-                <a:latin typeface="Arial" pitchFamily="34" charset="0"/>
+                <a:latin typeface="Nunito Sans" pitchFamily="34" charset="0"/>
                 <a:ea typeface="Arial" pitchFamily="34" charset="-122"/>
                 <a:cs typeface="Arial" pitchFamily="34" charset="-120"/>
               </a:rPr>
@@ -1990,7 +1990,7 @@
                 <a:solidFill>
                   <a:srgbClr val="12303D"/>
                 </a:solidFill>
-                <a:latin typeface="Arial" pitchFamily="34" charset="0"/>
+                <a:latin typeface="Nunito Sans" pitchFamily="34" charset="0"/>
                 <a:ea typeface="Arial" pitchFamily="34" charset="-122"/>
                 <a:cs typeface="Arial" pitchFamily="34" charset="-120"/>
               </a:rPr>
@@ -2057,7 +2057,7 @@
                 <a:solidFill>
                   <a:srgbClr val="12303D"/>
                 </a:solidFill>
-                <a:latin typeface="Arial" pitchFamily="34" charset="0"/>
+                <a:latin typeface="Nunito Sans" pitchFamily="34" charset="0"/>
                 <a:ea typeface="Arial" pitchFamily="34" charset="-122"/>
                 <a:cs typeface="Arial" pitchFamily="34" charset="-120"/>
               </a:rPr>
@@ -2068,7 +2068,7 @@
                 <a:solidFill>
                   <a:srgbClr val="12303D"/>
                 </a:solidFill>
-                <a:latin typeface="Arial" pitchFamily="34" charset="0"/>
+                <a:latin typeface="Nunito Sans" pitchFamily="34" charset="0"/>
                 <a:ea typeface="Arial" pitchFamily="34" charset="-122"/>
                 <a:cs typeface="Arial" pitchFamily="34" charset="-120"/>
               </a:rPr>
@@ -2112,7 +2112,7 @@
                 <a:solidFill>
                   <a:srgbClr val="B26A00"/>
                 </a:solidFill>
-                <a:latin typeface="Arial" pitchFamily="34" charset="0"/>
+                <a:latin typeface="Nunito Sans" pitchFamily="34" charset="0"/>
                 <a:ea typeface="Arial" pitchFamily="34" charset="-122"/>
                 <a:cs typeface="Arial" pitchFamily="34" charset="-120"/>
               </a:rPr>
@@ -2123,7 +2123,7 @@
                 <a:solidFill>
                   <a:srgbClr val="B26A00"/>
                 </a:solidFill>
-                <a:latin typeface="Arial" pitchFamily="34" charset="0"/>
+                <a:latin typeface="Nunito Sans" pitchFamily="34" charset="0"/>
                 <a:ea typeface="Arial" pitchFamily="34" charset="-122"/>
                 <a:cs typeface="Arial" pitchFamily="34" charset="-120"/>
               </a:rPr>
@@ -2190,7 +2190,7 @@
                 <a:solidFill>
                   <a:srgbClr val="A84B25"/>
                 </a:solidFill>
-                <a:latin typeface="Arial" pitchFamily="34" charset="0"/>
+                <a:latin typeface="Nunito Sans" pitchFamily="34" charset="0"/>
                 <a:ea typeface="Arial" pitchFamily="34" charset="-122"/>
                 <a:cs typeface="Arial" pitchFamily="34" charset="-120"/>
               </a:rPr>
@@ -2234,7 +2234,7 @@
                 <a:solidFill>
                   <a:srgbClr val="4A5565"/>
                 </a:solidFill>
-                <a:latin typeface="Arial" pitchFamily="34" charset="0"/>
+                <a:latin typeface="Nunito Sans" pitchFamily="34" charset="0"/>
                 <a:ea typeface="Arial" pitchFamily="34" charset="-122"/>
                 <a:cs typeface="Arial" pitchFamily="34" charset="-120"/>
               </a:rPr>
@@ -2301,7 +2301,7 @@
                 <a:solidFill>
                   <a:srgbClr val="12435A"/>
                 </a:solidFill>
-                <a:latin typeface="Arial" pitchFamily="34" charset="0"/>
+                <a:latin typeface="Nunito Sans" pitchFamily="34" charset="0"/>
                 <a:ea typeface="Arial" pitchFamily="34" charset="-122"/>
                 <a:cs typeface="Arial" pitchFamily="34" charset="-120"/>
               </a:rPr>
@@ -2345,7 +2345,7 @@
                 <a:solidFill>
                   <a:srgbClr val="4A5565"/>
                 </a:solidFill>
-                <a:latin typeface="Arial" pitchFamily="34" charset="0"/>
+                <a:latin typeface="Nunito Sans" pitchFamily="34" charset="0"/>
                 <a:ea typeface="Arial" pitchFamily="34" charset="-122"/>
                 <a:cs typeface="Arial" pitchFamily="34" charset="-120"/>
               </a:rPr>
@@ -2412,7 +2412,7 @@
                 <a:solidFill>
                   <a:srgbClr val="12435A"/>
                 </a:solidFill>
-                <a:latin typeface="Arial" pitchFamily="34" charset="0"/>
+                <a:latin typeface="Nunito Sans" pitchFamily="34" charset="0"/>
                 <a:ea typeface="Arial" pitchFamily="34" charset="-122"/>
                 <a:cs typeface="Arial" pitchFamily="34" charset="-120"/>
               </a:rPr>
@@ -2456,7 +2456,7 @@
                 <a:solidFill>
                   <a:srgbClr val="4A5565"/>
                 </a:solidFill>
-                <a:latin typeface="Arial" pitchFamily="34" charset="0"/>
+                <a:latin typeface="Nunito Sans" pitchFamily="34" charset="0"/>
                 <a:ea typeface="Arial" pitchFamily="34" charset="-122"/>
                 <a:cs typeface="Arial" pitchFamily="34" charset="-120"/>
               </a:rPr>
@@ -2523,7 +2523,7 @@
                 <a:solidFill>
                   <a:srgbClr val="4F6B3A"/>
                 </a:solidFill>
-                <a:latin typeface="Arial" pitchFamily="34" charset="0"/>
+                <a:latin typeface="Nunito Sans" pitchFamily="34" charset="0"/>
                 <a:ea typeface="Arial" pitchFamily="34" charset="-122"/>
                 <a:cs typeface="Arial" pitchFamily="34" charset="-120"/>
               </a:rPr>
@@ -2567,7 +2567,7 @@
                 <a:solidFill>
                   <a:srgbClr val="4A5565"/>
                 </a:solidFill>
-                <a:latin typeface="Arial" pitchFamily="34" charset="0"/>
+                <a:latin typeface="Nunito Sans" pitchFamily="34" charset="0"/>
                 <a:ea typeface="Arial" pitchFamily="34" charset="-122"/>
                 <a:cs typeface="Arial" pitchFamily="34" charset="-120"/>
               </a:rPr>
@@ -2634,7 +2634,7 @@
                 <a:solidFill>
                   <a:srgbClr val="4F6B3A"/>
                 </a:solidFill>
-                <a:latin typeface="Arial" pitchFamily="34" charset="0"/>
+                <a:latin typeface="Nunito Sans" pitchFamily="34" charset="0"/>
                 <a:ea typeface="Arial" pitchFamily="34" charset="-122"/>
                 <a:cs typeface="Arial" pitchFamily="34" charset="-120"/>
               </a:rPr>
@@ -2678,7 +2678,7 @@
                 <a:solidFill>
                   <a:srgbClr val="4A5565"/>
                 </a:solidFill>
-                <a:latin typeface="Arial" pitchFamily="34" charset="0"/>
+                <a:latin typeface="Nunito Sans" pitchFamily="34" charset="0"/>
                 <a:ea typeface="Arial" pitchFamily="34" charset="-122"/>
                 <a:cs typeface="Arial" pitchFamily="34" charset="-120"/>
               </a:rPr>
@@ -2745,7 +2745,7 @@
                 <a:solidFill>
                   <a:srgbClr val="4F6B3A"/>
                 </a:solidFill>
-                <a:latin typeface="Arial" pitchFamily="34" charset="0"/>
+                <a:latin typeface="Nunito Sans" pitchFamily="34" charset="0"/>
                 <a:ea typeface="Arial" pitchFamily="34" charset="-122"/>
                 <a:cs typeface="Arial" pitchFamily="34" charset="-120"/>
               </a:rPr>
@@ -2789,7 +2789,7 @@
                 <a:solidFill>
                   <a:srgbClr val="4A5565"/>
                 </a:solidFill>
-                <a:latin typeface="Arial" pitchFamily="34" charset="0"/>
+                <a:latin typeface="Nunito Sans" pitchFamily="34" charset="0"/>
                 <a:ea typeface="Arial" pitchFamily="34" charset="-122"/>
                 <a:cs typeface="Arial" pitchFamily="34" charset="-120"/>
               </a:rPr>
@@ -2856,7 +2856,7 @@
                 <a:solidFill>
                   <a:srgbClr val="12435A"/>
                 </a:solidFill>
-                <a:latin typeface="Arial" pitchFamily="34" charset="0"/>
+                <a:latin typeface="Nunito Sans" pitchFamily="34" charset="0"/>
                 <a:ea typeface="Arial" pitchFamily="34" charset="-122"/>
                 <a:cs typeface="Arial" pitchFamily="34" charset="-120"/>
               </a:rPr>
@@ -2900,7 +2900,7 @@
                 <a:solidFill>
                   <a:srgbClr val="4A5565"/>
                 </a:solidFill>
-                <a:latin typeface="Arial" pitchFamily="34" charset="0"/>
+                <a:latin typeface="Nunito Sans" pitchFamily="34" charset="0"/>
                 <a:ea typeface="Arial" pitchFamily="34" charset="-122"/>
                 <a:cs typeface="Arial" pitchFamily="34" charset="-120"/>
               </a:rPr>
@@ -2967,7 +2967,7 @@
                 <a:solidFill>
                   <a:srgbClr val="B26A00"/>
                 </a:solidFill>
-                <a:latin typeface="Arial" pitchFamily="34" charset="0"/>
+                <a:latin typeface="Nunito Sans" pitchFamily="34" charset="0"/>
                 <a:ea typeface="Arial" pitchFamily="34" charset="-122"/>
                 <a:cs typeface="Arial" pitchFamily="34" charset="-120"/>
               </a:rPr>
@@ -3011,7 +3011,7 @@
                 <a:solidFill>
                   <a:srgbClr val="4A5565"/>
                 </a:solidFill>
-                <a:latin typeface="Arial" pitchFamily="34" charset="0"/>
+                <a:latin typeface="Nunito Sans" pitchFamily="34" charset="0"/>
                 <a:ea typeface="Arial" pitchFamily="34" charset="-122"/>
                 <a:cs typeface="Arial" pitchFamily="34" charset="-120"/>
               </a:rPr>
@@ -3055,7 +3055,7 @@
                 <a:solidFill>
                   <a:srgbClr val="A84B25"/>
                 </a:solidFill>
-                <a:latin typeface="Arial" pitchFamily="34" charset="0"/>
+                <a:latin typeface="Nunito Sans" pitchFamily="34" charset="0"/>
                 <a:ea typeface="Arial" pitchFamily="34" charset="-122"/>
                 <a:cs typeface="Arial" pitchFamily="34" charset="-120"/>
               </a:rPr>
@@ -3066,7 +3066,7 @@
                 <a:solidFill>
                   <a:srgbClr val="4A5565"/>
                 </a:solidFill>
-                <a:latin typeface="Arial" pitchFamily="34" charset="0"/>
+                <a:latin typeface="Nunito Sans" pitchFamily="34" charset="0"/>
                 <a:ea typeface="Arial" pitchFamily="34" charset="-122"/>
                 <a:cs typeface="Arial" pitchFamily="34" charset="-120"/>
               </a:rPr>
@@ -3077,7 +3077,7 @@
                 <a:solidFill>
                   <a:srgbClr val="12435A"/>
                 </a:solidFill>
-                <a:latin typeface="Arial" pitchFamily="34" charset="0"/>
+                <a:latin typeface="Nunito Sans" pitchFamily="34" charset="0"/>
                 <a:ea typeface="Arial" pitchFamily="34" charset="-122"/>
                 <a:cs typeface="Arial" pitchFamily="34" charset="-120"/>
               </a:rPr>
@@ -3088,7 +3088,7 @@
                 <a:solidFill>
                   <a:srgbClr val="4A5565"/>
                 </a:solidFill>
-                <a:latin typeface="Arial" pitchFamily="34" charset="0"/>
+                <a:latin typeface="Nunito Sans" pitchFamily="34" charset="0"/>
                 <a:ea typeface="Arial" pitchFamily="34" charset="-122"/>
                 <a:cs typeface="Arial" pitchFamily="34" charset="-120"/>
               </a:rPr>
@@ -3099,7 +3099,7 @@
                 <a:solidFill>
                   <a:srgbClr val="4F6B3A"/>
                 </a:solidFill>
-                <a:latin typeface="Arial" pitchFamily="34" charset="0"/>
+                <a:latin typeface="Nunito Sans" pitchFamily="34" charset="0"/>
                 <a:ea typeface="Arial" pitchFamily="34" charset="-122"/>
                 <a:cs typeface="Arial" pitchFamily="34" charset="-120"/>
               </a:rPr>
@@ -3110,7 +3110,7 @@
                 <a:solidFill>
                   <a:srgbClr val="4A5565"/>
                 </a:solidFill>
-                <a:latin typeface="Arial" pitchFamily="34" charset="0"/>
+                <a:latin typeface="Nunito Sans" pitchFamily="34" charset="0"/>
                 <a:ea typeface="Arial" pitchFamily="34" charset="-122"/>
                 <a:cs typeface="Arial" pitchFamily="34" charset="-120"/>
               </a:rPr>
@@ -3121,7 +3121,7 @@
                 <a:solidFill>
                   <a:srgbClr val="B26A00"/>
                 </a:solidFill>
-                <a:latin typeface="Arial" pitchFamily="34" charset="0"/>
+                <a:latin typeface="Nunito Sans" pitchFamily="34" charset="0"/>
                 <a:ea typeface="Arial" pitchFamily="34" charset="-122"/>
                 <a:cs typeface="Arial" pitchFamily="34" charset="-120"/>
               </a:rPr>
@@ -3223,7 +3223,7 @@
                 <a:solidFill>
                   <a:srgbClr val="12303D"/>
                 </a:solidFill>
-                <a:latin typeface="Georgia" pitchFamily="34" charset="0"/>
+                <a:latin typeface="Domine" pitchFamily="34" charset="0"/>
                 <a:ea typeface="Georgia" pitchFamily="34" charset="-122"/>
                 <a:cs typeface="Georgia" pitchFamily="34" charset="-120"/>
               </a:rPr>
@@ -3298,7 +3298,7 @@
                 <a:solidFill>
                   <a:srgbClr val="12435A"/>
                 </a:solidFill>
-                <a:latin typeface="Arial" pitchFamily="34" charset="0"/>
+                <a:latin typeface="Nunito Sans" pitchFamily="34" charset="0"/>
                 <a:ea typeface="Arial" pitchFamily="34" charset="-122"/>
                 <a:cs typeface="Arial" pitchFamily="34" charset="-120"/>
               </a:rPr>
@@ -3342,7 +3342,7 @@
                 <a:solidFill>
                   <a:srgbClr val="12303D"/>
                 </a:solidFill>
-                <a:latin typeface="Georgia" pitchFamily="34" charset="0"/>
+                <a:latin typeface="Domine" pitchFamily="34" charset="0"/>
                 <a:ea typeface="Georgia" pitchFamily="34" charset="-122"/>
                 <a:cs typeface="Georgia" pitchFamily="34" charset="-120"/>
               </a:rPr>
@@ -3386,7 +3386,7 @@
                 <a:solidFill>
                   <a:srgbClr val="12435A"/>
                 </a:solidFill>
-                <a:latin typeface="Arial" pitchFamily="34" charset="0"/>
+                <a:latin typeface="Nunito Sans" pitchFamily="34" charset="0"/>
                 <a:ea typeface="Arial" pitchFamily="34" charset="-122"/>
                 <a:cs typeface="Arial" pitchFamily="34" charset="-120"/>
               </a:rPr>
@@ -3431,7 +3431,7 @@
                 <a:solidFill>
                   <a:srgbClr val="12303D"/>
                 </a:solidFill>
-                <a:latin typeface="Arial" pitchFamily="34" charset="0"/>
+                <a:latin typeface="Nunito Sans" pitchFamily="34" charset="0"/>
                 <a:ea typeface="Arial" pitchFamily="34" charset="-122"/>
                 <a:cs typeface="Arial" pitchFamily="34" charset="-120"/>
               </a:rPr>
@@ -3452,7 +3452,7 @@
                 <a:solidFill>
                   <a:srgbClr val="12303D"/>
                 </a:solidFill>
-                <a:latin typeface="Arial" pitchFamily="34" charset="0"/>
+                <a:latin typeface="Nunito Sans" pitchFamily="34" charset="0"/>
                 <a:ea typeface="Arial" pitchFamily="34" charset="-122"/>
                 <a:cs typeface="Arial" pitchFamily="34" charset="-120"/>
               </a:rPr>
@@ -3473,7 +3473,7 @@
                 <a:solidFill>
                   <a:srgbClr val="12303D"/>
                 </a:solidFill>
-                <a:latin typeface="Arial" pitchFamily="34" charset="0"/>
+                <a:latin typeface="Nunito Sans" pitchFamily="34" charset="0"/>
                 <a:ea typeface="Arial" pitchFamily="34" charset="-122"/>
                 <a:cs typeface="Arial" pitchFamily="34" charset="-120"/>
               </a:rPr>
@@ -3494,7 +3494,7 @@
                 <a:solidFill>
                   <a:srgbClr val="12303D"/>
                 </a:solidFill>
-                <a:latin typeface="Arial" pitchFamily="34" charset="0"/>
+                <a:latin typeface="Nunito Sans" pitchFamily="34" charset="0"/>
                 <a:ea typeface="Arial" pitchFamily="34" charset="-122"/>
                 <a:cs typeface="Arial" pitchFamily="34" charset="-120"/>
               </a:rPr>
@@ -3592,7 +3592,7 @@
                 <a:solidFill>
                   <a:srgbClr val="12435A"/>
                 </a:solidFill>
-                <a:latin typeface="Arial" pitchFamily="34" charset="0"/>
+                <a:latin typeface="Nunito Sans" pitchFamily="34" charset="0"/>
                 <a:ea typeface="Arial" pitchFamily="34" charset="-122"/>
                 <a:cs typeface="Arial" pitchFamily="34" charset="-120"/>
               </a:rPr>
@@ -3636,7 +3636,7 @@
                 <a:solidFill>
                   <a:srgbClr val="12303D"/>
                 </a:solidFill>
-                <a:latin typeface="Georgia" pitchFamily="34" charset="0"/>
+                <a:latin typeface="Domine" pitchFamily="34" charset="0"/>
                 <a:ea typeface="Georgia" pitchFamily="34" charset="-122"/>
                 <a:cs typeface="Georgia" pitchFamily="34" charset="-120"/>
               </a:rPr>
@@ -3680,7 +3680,7 @@
                 <a:solidFill>
                   <a:srgbClr val="12435A"/>
                 </a:solidFill>
-                <a:latin typeface="Arial" pitchFamily="34" charset="0"/>
+                <a:latin typeface="Nunito Sans" pitchFamily="34" charset="0"/>
                 <a:ea typeface="Arial" pitchFamily="34" charset="-122"/>
                 <a:cs typeface="Arial" pitchFamily="34" charset="-120"/>
               </a:rPr>
@@ -3725,7 +3725,7 @@
                 <a:solidFill>
                   <a:srgbClr val="12303D"/>
                 </a:solidFill>
-                <a:latin typeface="Arial" pitchFamily="34" charset="0"/>
+                <a:latin typeface="Nunito Sans" pitchFamily="34" charset="0"/>
                 <a:ea typeface="Arial" pitchFamily="34" charset="-122"/>
                 <a:cs typeface="Arial" pitchFamily="34" charset="-120"/>
               </a:rPr>
@@ -3746,7 +3746,7 @@
                 <a:solidFill>
                   <a:srgbClr val="12303D"/>
                 </a:solidFill>
-                <a:latin typeface="Arial" pitchFamily="34" charset="0"/>
+                <a:latin typeface="Nunito Sans" pitchFamily="34" charset="0"/>
                 <a:ea typeface="Arial" pitchFamily="34" charset="-122"/>
                 <a:cs typeface="Arial" pitchFamily="34" charset="-120"/>
               </a:rPr>
@@ -3767,7 +3767,7 @@
                 <a:solidFill>
                   <a:srgbClr val="12303D"/>
                 </a:solidFill>
-                <a:latin typeface="Arial" pitchFamily="34" charset="0"/>
+                <a:latin typeface="Nunito Sans" pitchFamily="34" charset="0"/>
                 <a:ea typeface="Arial" pitchFamily="34" charset="-122"/>
                 <a:cs typeface="Arial" pitchFamily="34" charset="-120"/>
               </a:rPr>
@@ -3788,7 +3788,7 @@
                 <a:solidFill>
                   <a:srgbClr val="12303D"/>
                 </a:solidFill>
-                <a:latin typeface="Arial" pitchFamily="34" charset="0"/>
+                <a:latin typeface="Nunito Sans" pitchFamily="34" charset="0"/>
                 <a:ea typeface="Arial" pitchFamily="34" charset="-122"/>
                 <a:cs typeface="Arial" pitchFamily="34" charset="-120"/>
               </a:rPr>
@@ -3886,7 +3886,7 @@
                 <a:solidFill>
                   <a:srgbClr val="B26A00"/>
                 </a:solidFill>
-                <a:latin typeface="Arial" pitchFamily="34" charset="0"/>
+                <a:latin typeface="Nunito Sans" pitchFamily="34" charset="0"/>
                 <a:ea typeface="Arial" pitchFamily="34" charset="-122"/>
                 <a:cs typeface="Arial" pitchFamily="34" charset="-120"/>
               </a:rPr>
@@ -3930,7 +3930,7 @@
                 <a:solidFill>
                   <a:srgbClr val="12303D"/>
                 </a:solidFill>
-                <a:latin typeface="Arial" pitchFamily="34" charset="0"/>
+                <a:latin typeface="Nunito Sans" pitchFamily="34" charset="0"/>
                 <a:ea typeface="Arial" pitchFamily="34" charset="-122"/>
                 <a:cs typeface="Arial" pitchFamily="34" charset="-120"/>
               </a:rPr>
@@ -3974,7 +3974,7 @@
                 <a:solidFill>
                   <a:srgbClr val="4A5565"/>
                 </a:solidFill>
-                <a:latin typeface="Arial" pitchFamily="34" charset="0"/>
+                <a:latin typeface="Nunito Sans" pitchFamily="34" charset="0"/>
                 <a:ea typeface="Arial" pitchFamily="34" charset="-122"/>
                 <a:cs typeface="Arial" pitchFamily="34" charset="-120"/>
               </a:rPr>
@@ -4041,7 +4041,7 @@
                 <a:solidFill>
                   <a:srgbClr val="12303D"/>
                 </a:solidFill>
-                <a:latin typeface="Arial" pitchFamily="34" charset="0"/>
+                <a:latin typeface="Nunito Sans" pitchFamily="34" charset="0"/>
                 <a:ea typeface="Arial" pitchFamily="34" charset="-122"/>
                 <a:cs typeface="Arial" pitchFamily="34" charset="-120"/>
               </a:rPr>
@@ -4052,7 +4052,7 @@
                 <a:solidFill>
                   <a:srgbClr val="12303D"/>
                 </a:solidFill>
-                <a:latin typeface="Arial" pitchFamily="34" charset="0"/>
+                <a:latin typeface="Nunito Sans" pitchFamily="34" charset="0"/>
                 <a:ea typeface="Arial" pitchFamily="34" charset="-122"/>
                 <a:cs typeface="Arial" pitchFamily="34" charset="-120"/>
               </a:rPr>
@@ -4154,7 +4154,7 @@
                 <a:solidFill>
                   <a:srgbClr val="12303D"/>
                 </a:solidFill>
-                <a:latin typeface="Georgia" pitchFamily="34" charset="0"/>
+                <a:latin typeface="Domine" pitchFamily="34" charset="0"/>
                 <a:ea typeface="Georgia" pitchFamily="34" charset="-122"/>
                 <a:cs typeface="Georgia" pitchFamily="34" charset="-120"/>
               </a:rPr>
@@ -4272,7 +4272,7 @@
                 <a:solidFill>
                   <a:srgbClr val="FFFBF5"/>
                 </a:solidFill>
-                <a:latin typeface="Arial" pitchFamily="34" charset="0"/>
+                <a:latin typeface="Nunito Sans" pitchFamily="34" charset="0"/>
                 <a:ea typeface="Arial" pitchFamily="34" charset="-122"/>
                 <a:cs typeface="Arial" pitchFamily="34" charset="-120"/>
               </a:rPr>
@@ -4340,7 +4340,7 @@
                 <a:solidFill>
                   <a:srgbClr val="12435A"/>
                 </a:solidFill>
-                <a:latin typeface="Arial" pitchFamily="34" charset="0"/>
+                <a:latin typeface="Nunito Sans" pitchFamily="34" charset="0"/>
                 <a:ea typeface="Arial" pitchFamily="34" charset="-122"/>
                 <a:cs typeface="Arial" pitchFamily="34" charset="-120"/>
               </a:rPr>
@@ -4384,7 +4384,7 @@
                 <a:solidFill>
                   <a:srgbClr val="4A5565"/>
                 </a:solidFill>
-                <a:latin typeface="Arial" pitchFamily="34" charset="0"/>
+                <a:latin typeface="Nunito Sans" pitchFamily="34" charset="0"/>
                 <a:ea typeface="Arial" pitchFamily="34" charset="-122"/>
                 <a:cs typeface="Arial" pitchFamily="34" charset="-120"/>
               </a:rPr>
@@ -4452,7 +4452,7 @@
                 <a:solidFill>
                   <a:srgbClr val="FFFBF5"/>
                 </a:solidFill>
-                <a:latin typeface="Arial" pitchFamily="34" charset="0"/>
+                <a:latin typeface="Nunito Sans" pitchFamily="34" charset="0"/>
                 <a:ea typeface="Arial" pitchFamily="34" charset="-122"/>
                 <a:cs typeface="Arial" pitchFamily="34" charset="-120"/>
               </a:rPr>
@@ -4520,7 +4520,7 @@
                 <a:solidFill>
                   <a:srgbClr val="A84B25"/>
                 </a:solidFill>
-                <a:latin typeface="Arial" pitchFamily="34" charset="0"/>
+                <a:latin typeface="Nunito Sans" pitchFamily="34" charset="0"/>
                 <a:ea typeface="Arial" pitchFamily="34" charset="-122"/>
                 <a:cs typeface="Arial" pitchFamily="34" charset="-120"/>
               </a:rPr>
@@ -4564,7 +4564,7 @@
                 <a:solidFill>
                   <a:srgbClr val="4A5565"/>
                 </a:solidFill>
-                <a:latin typeface="Arial" pitchFamily="34" charset="0"/>
+                <a:latin typeface="Nunito Sans" pitchFamily="34" charset="0"/>
                 <a:ea typeface="Arial" pitchFamily="34" charset="-122"/>
                 <a:cs typeface="Arial" pitchFamily="34" charset="-120"/>
               </a:rPr>
@@ -4659,7 +4659,7 @@
                 <a:solidFill>
                   <a:srgbClr val="FFFBF5"/>
                 </a:solidFill>
-                <a:latin typeface="Arial" pitchFamily="34" charset="0"/>
+                <a:latin typeface="Nunito Sans" pitchFamily="34" charset="0"/>
                 <a:ea typeface="Arial" pitchFamily="34" charset="-122"/>
                 <a:cs typeface="Arial" pitchFamily="34" charset="-120"/>
               </a:rPr>
@@ -4727,7 +4727,7 @@
                 <a:solidFill>
                   <a:srgbClr val="12435A"/>
                 </a:solidFill>
-                <a:latin typeface="Arial" pitchFamily="34" charset="0"/>
+                <a:latin typeface="Nunito Sans" pitchFamily="34" charset="0"/>
                 <a:ea typeface="Arial" pitchFamily="34" charset="-122"/>
                 <a:cs typeface="Arial" pitchFamily="34" charset="-120"/>
               </a:rPr>
@@ -4771,7 +4771,7 @@
                 <a:solidFill>
                   <a:srgbClr val="4A5565"/>
                 </a:solidFill>
-                <a:latin typeface="Arial" pitchFamily="34" charset="0"/>
+                <a:latin typeface="Nunito Sans" pitchFamily="34" charset="0"/>
                 <a:ea typeface="Arial" pitchFamily="34" charset="-122"/>
                 <a:cs typeface="Arial" pitchFamily="34" charset="-120"/>
               </a:rPr>
@@ -4839,7 +4839,7 @@
                 <a:solidFill>
                   <a:srgbClr val="FFFBF5"/>
                 </a:solidFill>
-                <a:latin typeface="Arial" pitchFamily="34" charset="0"/>
+                <a:latin typeface="Nunito Sans" pitchFamily="34" charset="0"/>
                 <a:ea typeface="Arial" pitchFamily="34" charset="-122"/>
                 <a:cs typeface="Arial" pitchFamily="34" charset="-120"/>
               </a:rPr>
@@ -4907,7 +4907,7 @@
                 <a:solidFill>
                   <a:srgbClr val="A84B25"/>
                 </a:solidFill>
-                <a:latin typeface="Arial" pitchFamily="34" charset="0"/>
+                <a:latin typeface="Nunito Sans" pitchFamily="34" charset="0"/>
                 <a:ea typeface="Arial" pitchFamily="34" charset="-122"/>
                 <a:cs typeface="Arial" pitchFamily="34" charset="-120"/>
               </a:rPr>
@@ -4951,7 +4951,7 @@
                 <a:solidFill>
                   <a:srgbClr val="4A5565"/>
                 </a:solidFill>
-                <a:latin typeface="Arial" pitchFamily="34" charset="0"/>
+                <a:latin typeface="Nunito Sans" pitchFamily="34" charset="0"/>
                 <a:ea typeface="Arial" pitchFamily="34" charset="-122"/>
                 <a:cs typeface="Arial" pitchFamily="34" charset="-120"/>
               </a:rPr>
@@ -5046,7 +5046,7 @@
                 <a:solidFill>
                   <a:srgbClr val="FFFBF5"/>
                 </a:solidFill>
-                <a:latin typeface="Arial" pitchFamily="34" charset="0"/>
+                <a:latin typeface="Nunito Sans" pitchFamily="34" charset="0"/>
                 <a:ea typeface="Arial" pitchFamily="34" charset="-122"/>
                 <a:cs typeface="Arial" pitchFamily="34" charset="-120"/>
               </a:rPr>
@@ -5114,7 +5114,7 @@
                 <a:solidFill>
                   <a:srgbClr val="12435A"/>
                 </a:solidFill>
-                <a:latin typeface="Arial" pitchFamily="34" charset="0"/>
+                <a:latin typeface="Nunito Sans" pitchFamily="34" charset="0"/>
                 <a:ea typeface="Arial" pitchFamily="34" charset="-122"/>
                 <a:cs typeface="Arial" pitchFamily="34" charset="-120"/>
               </a:rPr>
@@ -5158,7 +5158,7 @@
                 <a:solidFill>
                   <a:srgbClr val="4A5565"/>
                 </a:solidFill>
-                <a:latin typeface="Arial" pitchFamily="34" charset="0"/>
+                <a:latin typeface="Nunito Sans" pitchFamily="34" charset="0"/>
                 <a:ea typeface="Arial" pitchFamily="34" charset="-122"/>
                 <a:cs typeface="Arial" pitchFamily="34" charset="-120"/>
               </a:rPr>
@@ -5226,7 +5226,7 @@
                 <a:solidFill>
                   <a:srgbClr val="FFFBF5"/>
                 </a:solidFill>
-                <a:latin typeface="Arial" pitchFamily="34" charset="0"/>
+                <a:latin typeface="Nunito Sans" pitchFamily="34" charset="0"/>
                 <a:ea typeface="Arial" pitchFamily="34" charset="-122"/>
                 <a:cs typeface="Arial" pitchFamily="34" charset="-120"/>
               </a:rPr>
@@ -5294,7 +5294,7 @@
                 <a:solidFill>
                   <a:srgbClr val="4A5565"/>
                 </a:solidFill>
-                <a:latin typeface="Arial" pitchFamily="34" charset="0"/>
+                <a:latin typeface="Nunito Sans" pitchFamily="34" charset="0"/>
                 <a:ea typeface="Arial" pitchFamily="34" charset="-122"/>
                 <a:cs typeface="Arial" pitchFamily="34" charset="-120"/>
               </a:rPr>
@@ -5338,7 +5338,7 @@
                 <a:solidFill>
                   <a:srgbClr val="4A5565"/>
                 </a:solidFill>
-                <a:latin typeface="Arial" pitchFamily="34" charset="0"/>
+                <a:latin typeface="Nunito Sans" pitchFamily="34" charset="0"/>
                 <a:ea typeface="Arial" pitchFamily="34" charset="-122"/>
                 <a:cs typeface="Arial" pitchFamily="34" charset="-120"/>
               </a:rPr>
@@ -5433,7 +5433,7 @@
                 <a:solidFill>
                   <a:srgbClr val="FFFBF5"/>
                 </a:solidFill>
-                <a:latin typeface="Arial" pitchFamily="34" charset="0"/>
+                <a:latin typeface="Nunito Sans" pitchFamily="34" charset="0"/>
                 <a:ea typeface="Arial" pitchFamily="34" charset="-122"/>
                 <a:cs typeface="Arial" pitchFamily="34" charset="-120"/>
               </a:rPr>
@@ -5501,7 +5501,7 @@
                 <a:solidFill>
                   <a:srgbClr val="12435A"/>
                 </a:solidFill>
-                <a:latin typeface="Arial" pitchFamily="34" charset="0"/>
+                <a:latin typeface="Nunito Sans" pitchFamily="34" charset="0"/>
                 <a:ea typeface="Arial" pitchFamily="34" charset="-122"/>
                 <a:cs typeface="Arial" pitchFamily="34" charset="-120"/>
               </a:rPr>
@@ -5545,7 +5545,7 @@
                 <a:solidFill>
                   <a:srgbClr val="4A5565"/>
                 </a:solidFill>
-                <a:latin typeface="Arial" pitchFamily="34" charset="0"/>
+                <a:latin typeface="Nunito Sans" pitchFamily="34" charset="0"/>
                 <a:ea typeface="Arial" pitchFamily="34" charset="-122"/>
                 <a:cs typeface="Arial" pitchFamily="34" charset="-120"/>
               </a:rPr>
@@ -5613,7 +5613,7 @@
                 <a:solidFill>
                   <a:srgbClr val="FFFBF5"/>
                 </a:solidFill>
-                <a:latin typeface="Arial" pitchFamily="34" charset="0"/>
+                <a:latin typeface="Nunito Sans" pitchFamily="34" charset="0"/>
                 <a:ea typeface="Arial" pitchFamily="34" charset="-122"/>
                 <a:cs typeface="Arial" pitchFamily="34" charset="-120"/>
               </a:rPr>
@@ -5681,7 +5681,7 @@
                 <a:solidFill>
                   <a:srgbClr val="A84B25"/>
                 </a:solidFill>
-                <a:latin typeface="Arial" pitchFamily="34" charset="0"/>
+                <a:latin typeface="Nunito Sans" pitchFamily="34" charset="0"/>
                 <a:ea typeface="Arial" pitchFamily="34" charset="-122"/>
                 <a:cs typeface="Arial" pitchFamily="34" charset="-120"/>
               </a:rPr>
@@ -5725,7 +5725,7 @@
                 <a:solidFill>
                   <a:srgbClr val="4A5565"/>
                 </a:solidFill>
-                <a:latin typeface="Arial" pitchFamily="34" charset="0"/>
+                <a:latin typeface="Nunito Sans" pitchFamily="34" charset="0"/>
                 <a:ea typeface="Arial" pitchFamily="34" charset="-122"/>
                 <a:cs typeface="Arial" pitchFamily="34" charset="-120"/>
               </a:rPr>
@@ -5820,7 +5820,7 @@
                 <a:solidFill>
                   <a:srgbClr val="FFFBF5"/>
                 </a:solidFill>
-                <a:latin typeface="Arial" pitchFamily="34" charset="0"/>
+                <a:latin typeface="Nunito Sans" pitchFamily="34" charset="0"/>
                 <a:ea typeface="Arial" pitchFamily="34" charset="-122"/>
                 <a:cs typeface="Arial" pitchFamily="34" charset="-120"/>
               </a:rPr>
@@ -5888,7 +5888,7 @@
                 <a:solidFill>
                   <a:srgbClr val="4F6B3A"/>
                 </a:solidFill>
-                <a:latin typeface="Arial" pitchFamily="34" charset="0"/>
+                <a:latin typeface="Nunito Sans" pitchFamily="34" charset="0"/>
                 <a:ea typeface="Arial" pitchFamily="34" charset="-122"/>
                 <a:cs typeface="Arial" pitchFamily="34" charset="-120"/>
               </a:rPr>
@@ -5932,7 +5932,7 @@
                 <a:solidFill>
                   <a:srgbClr val="4A5565"/>
                 </a:solidFill>
-                <a:latin typeface="Arial" pitchFamily="34" charset="0"/>
+                <a:latin typeface="Nunito Sans" pitchFamily="34" charset="0"/>
                 <a:ea typeface="Arial" pitchFamily="34" charset="-122"/>
                 <a:cs typeface="Arial" pitchFamily="34" charset="-120"/>
               </a:rPr>
@@ -6000,7 +6000,7 @@
                 <a:solidFill>
                   <a:srgbClr val="FFFBF5"/>
                 </a:solidFill>
-                <a:latin typeface="Arial" pitchFamily="34" charset="0"/>
+                <a:latin typeface="Nunito Sans" pitchFamily="34" charset="0"/>
                 <a:ea typeface="Arial" pitchFamily="34" charset="-122"/>
                 <a:cs typeface="Arial" pitchFamily="34" charset="-120"/>
               </a:rPr>
@@ -6068,7 +6068,7 @@
                 <a:solidFill>
                   <a:srgbClr val="4F6B3A"/>
                 </a:solidFill>
-                <a:latin typeface="Arial" pitchFamily="34" charset="0"/>
+                <a:latin typeface="Nunito Sans" pitchFamily="34" charset="0"/>
                 <a:ea typeface="Arial" pitchFamily="34" charset="-122"/>
                 <a:cs typeface="Arial" pitchFamily="34" charset="-120"/>
               </a:rPr>
@@ -6112,7 +6112,7 @@
                 <a:solidFill>
                   <a:srgbClr val="4A5565"/>
                 </a:solidFill>
-                <a:latin typeface="Arial" pitchFamily="34" charset="0"/>
+                <a:latin typeface="Nunito Sans" pitchFamily="34" charset="0"/>
                 <a:ea typeface="Arial" pitchFamily="34" charset="-122"/>
                 <a:cs typeface="Arial" pitchFamily="34" charset="-120"/>
               </a:rPr>
@@ -6209,7 +6209,7 @@
                 <a:solidFill>
                   <a:srgbClr val="B26A00"/>
                 </a:solidFill>
-                <a:latin typeface="Arial" pitchFamily="34" charset="0"/>
+                <a:latin typeface="Nunito Sans" pitchFamily="34" charset="0"/>
                 <a:ea typeface="Arial" pitchFamily="34" charset="-122"/>
                 <a:cs typeface="Arial" pitchFamily="34" charset="-120"/>
               </a:rPr>
@@ -6253,7 +6253,7 @@
                 <a:solidFill>
                   <a:srgbClr val="12303D"/>
                 </a:solidFill>
-                <a:latin typeface="Arial" pitchFamily="34" charset="0"/>
+                <a:latin typeface="Nunito Sans" pitchFamily="34" charset="0"/>
                 <a:ea typeface="Arial" pitchFamily="34" charset="-122"/>
                 <a:cs typeface="Arial" pitchFamily="34" charset="-120"/>
               </a:rPr>
@@ -6264,7 +6264,7 @@
                 <a:solidFill>
                   <a:srgbClr val="12303D"/>
                 </a:solidFill>
-                <a:latin typeface="Arial" pitchFamily="34" charset="0"/>
+                <a:latin typeface="Nunito Sans" pitchFamily="34" charset="0"/>
                 <a:ea typeface="Arial" pitchFamily="34" charset="-122"/>
                 <a:cs typeface="Arial" pitchFamily="34" charset="-120"/>
               </a:rPr>
@@ -6308,7 +6308,7 @@
                 <a:solidFill>
                   <a:srgbClr val="4A5565"/>
                 </a:solidFill>
-                <a:latin typeface="Arial" pitchFamily="34" charset="0"/>
+                <a:latin typeface="Nunito Sans" pitchFamily="34" charset="0"/>
                 <a:ea typeface="Arial" pitchFamily="34" charset="-122"/>
                 <a:cs typeface="Arial" pitchFamily="34" charset="-120"/>
               </a:rPr>
@@ -6371,6 +6371,10 @@
           </a:solidFill>
           <a:ln/>
         </p:spPr>
+        <p:txBody>
+          <a:bodyPr/>
+          <a:p/>
+        </p:txBody>
       </p:sp>
       <p:sp>
         <p:nvSpPr>
@@ -6406,7 +6410,7 @@
                 <a:solidFill>
                   <a:srgbClr val="12303D"/>
                 </a:solidFill>
-                <a:latin typeface="Georgia" pitchFamily="34" charset="0"/>
+                <a:latin typeface="Domine" pitchFamily="34" charset="0"/>
                 <a:ea typeface="Georgia" pitchFamily="34" charset="-122"/>
                 <a:cs typeface="Georgia" pitchFamily="34" charset="-120"/>
               </a:rPr>
@@ -6450,11 +6454,11 @@
                 <a:solidFill>
                   <a:srgbClr val="4A5565"/>
                 </a:solidFill>
-                <a:latin typeface="Arial" pitchFamily="34" charset="0"/>
-                <a:ea typeface="Arial" pitchFamily="34" charset="-122"/>
-                <a:cs typeface="Arial" pitchFamily="34" charset="-120"/>
-              </a:rPr>
-              <a:t>Who acts and who watches swaps when an area is handed over. Trainers always belong to the BDS partner; the register of groups always stays with TAMISEMI's district officers.</a:t>
+                <a:latin typeface="Nunito Sans" pitchFamily="34" charset="0"/>
+                <a:ea typeface="Arial" pitchFamily="34" charset="-122"/>
+                <a:cs typeface="Arial" pitchFamily="34" charset="-120"/>
+              </a:rPr>
+              <a:t>The assumption here is that the BDS provider is on the hook for training, although we might get things started out with consultant + TAMISEMI master trainers. The system therefore provides for a hand-over; the register of groups always stays with TAMISEMI's district officers.</a:t>
             </a:r>
             <a:endParaRPr lang="en-US" sz="1500" dirty="0"/>
           </a:p>
@@ -6481,6 +6485,10 @@
           </a:solidFill>
           <a:ln/>
         </p:spPr>
+        <p:txBody>
+          <a:bodyPr/>
+          <a:p/>
+        </p:txBody>
       </p:sp>
       <p:sp>
         <p:nvSpPr>
@@ -6516,7 +6524,7 @@
                 <a:solidFill>
                   <a:srgbClr val="12303D"/>
                 </a:solidFill>
-                <a:latin typeface="Georgia" pitchFamily="34" charset="0"/>
+                <a:latin typeface="Domine" pitchFamily="34" charset="0"/>
                 <a:ea typeface="Georgia" pitchFamily="34" charset="-122"/>
                 <a:cs typeface="Georgia" pitchFamily="34" charset="-120"/>
               </a:rPr>
@@ -6552,6 +6560,10 @@
             <a:prstDash val="solid"/>
           </a:ln>
         </p:spPr>
+        <p:txBody>
+          <a:bodyPr/>
+          <a:p/>
+        </p:txBody>
       </p:sp>
       <p:sp>
         <p:nvSpPr>
@@ -6587,7 +6599,7 @@
                 <a:solidFill>
                   <a:srgbClr val="FFFBF5"/>
                 </a:solidFill>
-                <a:latin typeface="Arial" pitchFamily="34" charset="0"/>
+                <a:latin typeface="Nunito Sans" pitchFamily="34" charset="0"/>
                 <a:ea typeface="Arial" pitchFamily="34" charset="-122"/>
                 <a:cs typeface="Arial" pitchFamily="34" charset="-120"/>
               </a:rPr>
@@ -6631,7 +6643,7 @@
                 <a:solidFill>
                   <a:srgbClr val="F3E9DA"/>
                 </a:solidFill>
-                <a:latin typeface="Arial" pitchFamily="34" charset="0"/>
+                <a:latin typeface="Nunito Sans" pitchFamily="34" charset="0"/>
                 <a:ea typeface="Arial" pitchFamily="34" charset="-122"/>
                 <a:cs typeface="Arial" pitchFamily="34" charset="-120"/>
               </a:rPr>
@@ -6667,6 +6679,10 @@
             <a:prstDash val="solid"/>
           </a:ln>
         </p:spPr>
+        <p:txBody>
+          <a:bodyPr/>
+          <a:p/>
+        </p:txBody>
       </p:sp>
       <p:sp>
         <p:nvSpPr>
@@ -6702,7 +6718,7 @@
                 <a:solidFill>
                   <a:srgbClr val="FFFBF5"/>
                 </a:solidFill>
-                <a:latin typeface="Arial" pitchFamily="34" charset="0"/>
+                <a:latin typeface="Nunito Sans" pitchFamily="34" charset="0"/>
                 <a:ea typeface="Arial" pitchFamily="34" charset="-122"/>
                 <a:cs typeface="Arial" pitchFamily="34" charset="-120"/>
               </a:rPr>
@@ -6746,7 +6762,7 @@
                 <a:solidFill>
                   <a:srgbClr val="F3E9DA"/>
                 </a:solidFill>
-                <a:latin typeface="Arial" pitchFamily="34" charset="0"/>
+                <a:latin typeface="Nunito Sans" pitchFamily="34" charset="0"/>
                 <a:ea typeface="Arial" pitchFamily="34" charset="-122"/>
                 <a:cs typeface="Arial" pitchFamily="34" charset="-120"/>
               </a:rPr>
@@ -6782,6 +6798,10 @@
             <a:prstDash val="solid"/>
           </a:ln>
         </p:spPr>
+        <p:txBody>
+          <a:bodyPr/>
+          <a:p/>
+        </p:txBody>
       </p:sp>
       <p:sp>
         <p:nvSpPr>
@@ -6817,7 +6837,7 @@
                 <a:solidFill>
                   <a:srgbClr val="FFFBF5"/>
                 </a:solidFill>
-                <a:latin typeface="Arial" pitchFamily="34" charset="0"/>
+                <a:latin typeface="Nunito Sans" pitchFamily="34" charset="0"/>
                 <a:ea typeface="Arial" pitchFamily="34" charset="-122"/>
                 <a:cs typeface="Arial" pitchFamily="34" charset="-120"/>
               </a:rPr>
@@ -6861,7 +6881,7 @@
                 <a:solidFill>
                   <a:srgbClr val="F3E9DA"/>
                 </a:solidFill>
-                <a:latin typeface="Arial" pitchFamily="34" charset="0"/>
+                <a:latin typeface="Nunito Sans" pitchFamily="34" charset="0"/>
                 <a:ea typeface="Arial" pitchFamily="34" charset="-122"/>
                 <a:cs typeface="Arial" pitchFamily="34" charset="-120"/>
               </a:rPr>
@@ -6897,6 +6917,10 @@
             <a:prstDash val="sysDot"/>
           </a:ln>
         </p:spPr>
+        <p:txBody>
+          <a:bodyPr/>
+          <a:p/>
+        </p:txBody>
       </p:sp>
       <p:sp>
         <p:nvSpPr>
@@ -6932,7 +6956,7 @@
                 <a:solidFill>
                   <a:srgbClr val="4A5565"/>
                 </a:solidFill>
-                <a:latin typeface="Arial" pitchFamily="34" charset="0"/>
+                <a:latin typeface="Nunito Sans" pitchFamily="34" charset="0"/>
                 <a:ea typeface="Arial" pitchFamily="34" charset="-122"/>
                 <a:cs typeface="Arial" pitchFamily="34" charset="-120"/>
               </a:rPr>
@@ -6968,6 +6992,10 @@
             <a:prstDash val="solid"/>
           </a:ln>
         </p:spPr>
+        <p:txBody>
+          <a:bodyPr/>
+          <a:p/>
+        </p:txBody>
       </p:sp>
       <p:sp>
         <p:nvSpPr>
@@ -7003,7 +7031,7 @@
                 <a:solidFill>
                   <a:srgbClr val="FFFBF5"/>
                 </a:solidFill>
-                <a:latin typeface="Arial" pitchFamily="34" charset="0"/>
+                <a:latin typeface="Nunito Sans" pitchFamily="34" charset="0"/>
                 <a:ea typeface="Arial" pitchFamily="34" charset="-122"/>
                 <a:cs typeface="Arial" pitchFamily="34" charset="-120"/>
               </a:rPr>
@@ -7047,7 +7075,7 @@
                 <a:solidFill>
                   <a:srgbClr val="F3E9DA"/>
                 </a:solidFill>
-                <a:latin typeface="Arial" pitchFamily="34" charset="0"/>
+                <a:latin typeface="Nunito Sans" pitchFamily="34" charset="0"/>
                 <a:ea typeface="Arial" pitchFamily="34" charset="-122"/>
                 <a:cs typeface="Arial" pitchFamily="34" charset="-120"/>
               </a:rPr>
@@ -7083,6 +7111,10 @@
             <a:prstDash val="dash"/>
           </a:ln>
         </p:spPr>
+        <p:txBody>
+          <a:bodyPr/>
+          <a:p/>
+        </p:txBody>
       </p:sp>
       <p:sp>
         <p:nvSpPr>
@@ -7118,7 +7150,7 @@
                 <a:solidFill>
                   <a:srgbClr val="A84B25"/>
                 </a:solidFill>
-                <a:latin typeface="Arial" pitchFamily="34" charset="0"/>
+                <a:latin typeface="Nunito Sans" pitchFamily="34" charset="0"/>
                 <a:ea typeface="Arial" pitchFamily="34" charset="-122"/>
                 <a:cs typeface="Arial" pitchFamily="34" charset="-120"/>
               </a:rPr>
@@ -7162,7 +7194,7 @@
                 <a:solidFill>
                   <a:srgbClr val="4A5565"/>
                 </a:solidFill>
-                <a:latin typeface="Arial" pitchFamily="34" charset="0"/>
+                <a:latin typeface="Nunito Sans" pitchFamily="34" charset="0"/>
                 <a:ea typeface="Arial" pitchFamily="34" charset="-122"/>
                 <a:cs typeface="Arial" pitchFamily="34" charset="-120"/>
               </a:rPr>
@@ -7206,7 +7238,7 @@
                 <a:solidFill>
                   <a:srgbClr val="B26A00"/>
                 </a:solidFill>
-                <a:latin typeface="Arial" pitchFamily="34" charset="0"/>
+                <a:latin typeface="Nunito Sans" pitchFamily="34" charset="0"/>
                 <a:ea typeface="Arial" pitchFamily="34" charset="-122"/>
                 <a:cs typeface="Arial" pitchFamily="34" charset="-120"/>
               </a:rPr>
@@ -7273,7 +7305,7 @@
                 <a:solidFill>
                   <a:srgbClr val="4A5565"/>
                 </a:solidFill>
-                <a:latin typeface="Arial" pitchFamily="34" charset="0"/>
+                <a:latin typeface="Nunito Sans" pitchFamily="34" charset="0"/>
                 <a:ea typeface="Arial" pitchFamily="34" charset="-122"/>
                 <a:cs typeface="Arial" pitchFamily="34" charset="-120"/>
               </a:rPr>
@@ -7304,6 +7336,10 @@
           </a:solidFill>
           <a:ln/>
         </p:spPr>
+        <p:txBody>
+          <a:bodyPr/>
+          <a:p/>
+        </p:txBody>
       </p:sp>
       <p:sp>
         <p:nvSpPr>
@@ -7339,7 +7375,7 @@
                 <a:solidFill>
                   <a:srgbClr val="12303D"/>
                 </a:solidFill>
-                <a:latin typeface="Georgia" pitchFamily="34" charset="0"/>
+                <a:latin typeface="Domine" pitchFamily="34" charset="0"/>
                 <a:ea typeface="Georgia" pitchFamily="34" charset="-122"/>
                 <a:cs typeface="Georgia" pitchFamily="34" charset="-120"/>
               </a:rPr>
@@ -7375,6 +7411,10 @@
             <a:prstDash val="solid"/>
           </a:ln>
         </p:spPr>
+        <p:txBody>
+          <a:bodyPr/>
+          <a:p/>
+        </p:txBody>
       </p:sp>
       <p:sp>
         <p:nvSpPr>
@@ -7410,7 +7450,7 @@
                 <a:solidFill>
                   <a:srgbClr val="B26A00"/>
                 </a:solidFill>
-                <a:latin typeface="Arial" pitchFamily="34" charset="0"/>
+                <a:latin typeface="Nunito Sans" pitchFamily="34" charset="0"/>
                 <a:ea typeface="Arial" pitchFamily="34" charset="-122"/>
                 <a:cs typeface="Arial" pitchFamily="34" charset="-120"/>
               </a:rPr>
@@ -7454,7 +7494,7 @@
                 <a:solidFill>
                   <a:srgbClr val="4A5565"/>
                 </a:solidFill>
-                <a:latin typeface="Arial" pitchFamily="34" charset="0"/>
+                <a:latin typeface="Nunito Sans" pitchFamily="34" charset="0"/>
                 <a:ea typeface="Arial" pitchFamily="34" charset="-122"/>
                 <a:cs typeface="Arial" pitchFamily="34" charset="-120"/>
               </a:rPr>
@@ -7490,6 +7530,10 @@
             <a:prstDash val="solid"/>
           </a:ln>
         </p:spPr>
+        <p:txBody>
+          <a:bodyPr/>
+          <a:p/>
+        </p:txBody>
       </p:sp>
       <p:sp>
         <p:nvSpPr>
@@ -7525,7 +7569,7 @@
                 <a:solidFill>
                   <a:srgbClr val="FFFBF5"/>
                 </a:solidFill>
-                <a:latin typeface="Arial" pitchFamily="34" charset="0"/>
+                <a:latin typeface="Nunito Sans" pitchFamily="34" charset="0"/>
                 <a:ea typeface="Arial" pitchFamily="34" charset="-122"/>
                 <a:cs typeface="Arial" pitchFamily="34" charset="-120"/>
               </a:rPr>
@@ -7569,7 +7613,7 @@
                 <a:solidFill>
                   <a:srgbClr val="F3E9DA"/>
                 </a:solidFill>
-                <a:latin typeface="Arial" pitchFamily="34" charset="0"/>
+                <a:latin typeface="Nunito Sans" pitchFamily="34" charset="0"/>
                 <a:ea typeface="Arial" pitchFamily="34" charset="-122"/>
                 <a:cs typeface="Arial" pitchFamily="34" charset="-120"/>
               </a:rPr>
@@ -7605,6 +7649,10 @@
             <a:prstDash val="solid"/>
           </a:ln>
         </p:spPr>
+        <p:txBody>
+          <a:bodyPr/>
+          <a:p/>
+        </p:txBody>
       </p:sp>
       <p:sp>
         <p:nvSpPr>
@@ -7640,7 +7688,7 @@
                 <a:solidFill>
                   <a:srgbClr val="FFFBF5"/>
                 </a:solidFill>
-                <a:latin typeface="Arial" pitchFamily="34" charset="0"/>
+                <a:latin typeface="Nunito Sans" pitchFamily="34" charset="0"/>
                 <a:ea typeface="Arial" pitchFamily="34" charset="-122"/>
                 <a:cs typeface="Arial" pitchFamily="34" charset="-120"/>
               </a:rPr>
@@ -7684,7 +7732,7 @@
                 <a:solidFill>
                   <a:srgbClr val="F3E9DA"/>
                 </a:solidFill>
-                <a:latin typeface="Arial" pitchFamily="34" charset="0"/>
+                <a:latin typeface="Nunito Sans" pitchFamily="34" charset="0"/>
                 <a:ea typeface="Arial" pitchFamily="34" charset="-122"/>
                 <a:cs typeface="Arial" pitchFamily="34" charset="-120"/>
               </a:rPr>
@@ -7720,6 +7768,10 @@
             <a:prstDash val="sysDot"/>
           </a:ln>
         </p:spPr>
+        <p:txBody>
+          <a:bodyPr/>
+          <a:p/>
+        </p:txBody>
       </p:sp>
       <p:sp>
         <p:nvSpPr>
@@ -7755,7 +7807,7 @@
                 <a:solidFill>
                   <a:srgbClr val="4A5565"/>
                 </a:solidFill>
-                <a:latin typeface="Arial" pitchFamily="34" charset="0"/>
+                <a:latin typeface="Nunito Sans" pitchFamily="34" charset="0"/>
                 <a:ea typeface="Arial" pitchFamily="34" charset="-122"/>
                 <a:cs typeface="Arial" pitchFamily="34" charset="-120"/>
               </a:rPr>
@@ -7791,6 +7843,10 @@
             <a:prstDash val="dash"/>
           </a:ln>
         </p:spPr>
+        <p:txBody>
+          <a:bodyPr/>
+          <a:p/>
+        </p:txBody>
       </p:sp>
       <p:sp>
         <p:nvSpPr>
@@ -7826,7 +7882,7 @@
                 <a:solidFill>
                   <a:srgbClr val="12435A"/>
                 </a:solidFill>
-                <a:latin typeface="Arial" pitchFamily="34" charset="0"/>
+                <a:latin typeface="Nunito Sans" pitchFamily="34" charset="0"/>
                 <a:ea typeface="Arial" pitchFamily="34" charset="-122"/>
                 <a:cs typeface="Arial" pitchFamily="34" charset="-120"/>
               </a:rPr>
@@ -7870,7 +7926,7 @@
                 <a:solidFill>
                   <a:srgbClr val="4A5565"/>
                 </a:solidFill>
-                <a:latin typeface="Arial" pitchFamily="34" charset="0"/>
+                <a:latin typeface="Nunito Sans" pitchFamily="34" charset="0"/>
                 <a:ea typeface="Arial" pitchFamily="34" charset="-122"/>
                 <a:cs typeface="Arial" pitchFamily="34" charset="-120"/>
               </a:rPr>
@@ -7906,6 +7962,10 @@
             <a:prstDash val="solid"/>
           </a:ln>
         </p:spPr>
+        <p:txBody>
+          <a:bodyPr/>
+          <a:p/>
+        </p:txBody>
       </p:sp>
       <p:sp>
         <p:nvSpPr>
@@ -7941,7 +8001,7 @@
                 <a:solidFill>
                   <a:srgbClr val="FFFBF5"/>
                 </a:solidFill>
-                <a:latin typeface="Arial" pitchFamily="34" charset="0"/>
+                <a:latin typeface="Nunito Sans" pitchFamily="34" charset="0"/>
                 <a:ea typeface="Arial" pitchFamily="34" charset="-122"/>
                 <a:cs typeface="Arial" pitchFamily="34" charset="-120"/>
               </a:rPr>
@@ -7985,7 +8045,7 @@
                 <a:solidFill>
                   <a:srgbClr val="F3E9DA"/>
                 </a:solidFill>
-                <a:latin typeface="Arial" pitchFamily="34" charset="0"/>
+                <a:latin typeface="Nunito Sans" pitchFamily="34" charset="0"/>
                 <a:ea typeface="Arial" pitchFamily="34" charset="-122"/>
                 <a:cs typeface="Arial" pitchFamily="34" charset="-120"/>
               </a:rPr>
@@ -8016,6 +8076,10 @@
           </a:solidFill>
           <a:ln/>
         </p:spPr>
+        <p:txBody>
+          <a:bodyPr/>
+          <a:p/>
+        </p:txBody>
       </p:sp>
       <p:sp>
         <p:nvSpPr>
@@ -8051,7 +8115,7 @@
                 <a:solidFill>
                   <a:srgbClr val="12303D"/>
                 </a:solidFill>
-                <a:latin typeface="Arial" pitchFamily="34" charset="0"/>
+                <a:latin typeface="Nunito Sans" pitchFamily="34" charset="0"/>
                 <a:ea typeface="Arial" pitchFamily="34" charset="-122"/>
                 <a:cs typeface="Arial" pitchFamily="34" charset="-120"/>
               </a:rPr>
@@ -8082,6 +8146,10 @@
           </a:solidFill>
           <a:ln/>
         </p:spPr>
+        <p:txBody>
+          <a:bodyPr/>
+          <a:p/>
+        </p:txBody>
       </p:sp>
       <p:sp>
         <p:nvSpPr>
@@ -8117,7 +8185,7 @@
                 <a:solidFill>
                   <a:srgbClr val="12303D"/>
                 </a:solidFill>
-                <a:latin typeface="Arial" pitchFamily="34" charset="0"/>
+                <a:latin typeface="Nunito Sans" pitchFamily="34" charset="0"/>
                 <a:ea typeface="Arial" pitchFamily="34" charset="-122"/>
                 <a:cs typeface="Arial" pitchFamily="34" charset="-120"/>
               </a:rPr>
@@ -8146,6 +8214,10 @@
           </a:solidFill>
           <a:ln/>
         </p:spPr>
+        <p:txBody>
+          <a:bodyPr/>
+          <a:p/>
+        </p:txBody>
       </p:sp>
       <p:sp>
         <p:nvSpPr>
@@ -8173,6 +8245,10 @@
             <a:prstDash val="solid"/>
           </a:ln>
         </p:spPr>
+        <p:txBody>
+          <a:bodyPr/>
+          <a:p/>
+        </p:txBody>
       </p:sp>
       <p:sp>
         <p:nvSpPr>
@@ -8208,7 +8284,7 @@
                 <a:solidFill>
                   <a:srgbClr val="12303D"/>
                 </a:solidFill>
-                <a:latin typeface="Arial" pitchFamily="34" charset="0"/>
+                <a:latin typeface="Nunito Sans" pitchFamily="34" charset="0"/>
                 <a:ea typeface="Arial" pitchFamily="34" charset="-122"/>
                 <a:cs typeface="Arial" pitchFamily="34" charset="-120"/>
               </a:rPr>
@@ -8244,6 +8320,10 @@
             <a:prstDash val="dash"/>
           </a:ln>
         </p:spPr>
+        <p:txBody>
+          <a:bodyPr/>
+          <a:p/>
+        </p:txBody>
       </p:sp>
       <p:sp>
         <p:nvSpPr>
@@ -8279,7 +8359,7 @@
                 <a:solidFill>
                   <a:srgbClr val="12303D"/>
                 </a:solidFill>
-                <a:latin typeface="Arial" pitchFamily="34" charset="0"/>
+                <a:latin typeface="Nunito Sans" pitchFamily="34" charset="0"/>
                 <a:ea typeface="Arial" pitchFamily="34" charset="-122"/>
                 <a:cs typeface="Arial" pitchFamily="34" charset="-120"/>
               </a:rPr>
@@ -8315,6 +8395,10 @@
             <a:prstDash val="solid"/>
           </a:ln>
         </p:spPr>
+        <p:txBody>
+          <a:bodyPr/>
+          <a:p/>
+        </p:txBody>
       </p:sp>
       <p:sp>
         <p:nvSpPr>
@@ -8350,7 +8434,7 @@
                 <a:solidFill>
                   <a:srgbClr val="12303D"/>
                 </a:solidFill>
-                <a:latin typeface="Arial" pitchFamily="34" charset="0"/>
+                <a:latin typeface="Nunito Sans" pitchFamily="34" charset="0"/>
                 <a:ea typeface="Arial" pitchFamily="34" charset="-122"/>
                 <a:cs typeface="Arial" pitchFamily="34" charset="-120"/>
               </a:rPr>
@@ -8452,7 +8536,7 @@
                 <a:solidFill>
                   <a:srgbClr val="12303D"/>
                 </a:solidFill>
-                <a:latin typeface="Georgia" pitchFamily="34" charset="0"/>
+                <a:latin typeface="Domine" pitchFamily="34" charset="0"/>
                 <a:ea typeface="Georgia" pitchFamily="34" charset="-122"/>
                 <a:cs typeface="Georgia" pitchFamily="34" charset="-120"/>
               </a:rPr>
@@ -8496,11 +8580,11 @@
                 <a:solidFill>
                   <a:srgbClr val="4A5565"/>
                 </a:solidFill>
-                <a:latin typeface="Arial" pitchFamily="34" charset="0"/>
-                <a:ea typeface="Arial" pitchFamily="34" charset="-122"/>
-                <a:cs typeface="Arial" pitchFamily="34" charset="-120"/>
-              </a:rPr>
-              <a:t>Eight people help deliver a lesson from a training content author's desk to a village meeting and back. The roles are listed here.</a:t>
+                <a:latin typeface="Nunito Sans" pitchFamily="34" charset="0"/>
+                <a:ea typeface="Arial" pitchFamily="34" charset="-122"/>
+                <a:cs typeface="Arial" pitchFamily="34" charset="-120"/>
+              </a:rPr>
+              <a:t>Many people help deliver a lesson from a training content author's desk to a village meeting and back. Key roles are listed here.</a:t>
             </a:r>
             <a:endParaRPr lang="en-US" sz="1500" dirty="0"/>
           </a:p>
@@ -9147,7 +9231,7 @@
                 <a:solidFill>
                   <a:srgbClr val="12303D"/>
                 </a:solidFill>
-                <a:latin typeface="Arial" pitchFamily="34" charset="0"/>
+                <a:latin typeface="Nunito Sans" pitchFamily="34" charset="0"/>
                 <a:ea typeface="Arial" pitchFamily="34" charset="-122"/>
                 <a:cs typeface="Arial" pitchFamily="34" charset="-120"/>
               </a:rPr>
@@ -9191,7 +9275,7 @@
                 <a:solidFill>
                   <a:srgbClr val="12303D"/>
                 </a:solidFill>
-                <a:latin typeface="Arial" pitchFamily="34" charset="0"/>
+                <a:latin typeface="Nunito Sans" pitchFamily="34" charset="0"/>
                 <a:ea typeface="Arial" pitchFamily="34" charset="-122"/>
                 <a:cs typeface="Arial" pitchFamily="34" charset="-120"/>
               </a:rPr>
@@ -9235,7 +9319,7 @@
                 <a:solidFill>
                   <a:srgbClr val="12303D"/>
                 </a:solidFill>
-                <a:latin typeface="Arial" pitchFamily="34" charset="0"/>
+                <a:latin typeface="Nunito Sans" pitchFamily="34" charset="0"/>
                 <a:ea typeface="Arial" pitchFamily="34" charset="-122"/>
                 <a:cs typeface="Arial" pitchFamily="34" charset="-120"/>
               </a:rPr>
@@ -9279,7 +9363,7 @@
                 <a:solidFill>
                   <a:srgbClr val="A84B25"/>
                 </a:solidFill>
-                <a:latin typeface="Arial" pitchFamily="34" charset="0"/>
+                <a:latin typeface="Nunito Sans" pitchFamily="34" charset="0"/>
                 <a:ea typeface="Arial" pitchFamily="34" charset="-122"/>
                 <a:cs typeface="Arial" pitchFamily="34" charset="-120"/>
               </a:rPr>
@@ -9323,7 +9407,7 @@
                 <a:solidFill>
                   <a:srgbClr val="12435A"/>
                 </a:solidFill>
-                <a:latin typeface="Arial" pitchFamily="34" charset="0"/>
+                <a:latin typeface="Nunito Sans" pitchFamily="34" charset="0"/>
                 <a:ea typeface="Arial" pitchFamily="34" charset="-122"/>
                 <a:cs typeface="Arial" pitchFamily="34" charset="-120"/>
               </a:rPr>
@@ -9367,7 +9451,7 @@
                 <a:solidFill>
                   <a:srgbClr val="4F6B3A"/>
                 </a:solidFill>
-                <a:latin typeface="Arial" pitchFamily="34" charset="0"/>
+                <a:latin typeface="Nunito Sans" pitchFamily="34" charset="0"/>
                 <a:ea typeface="Arial" pitchFamily="34" charset="-122"/>
                 <a:cs typeface="Arial" pitchFamily="34" charset="-120"/>
               </a:rPr>
@@ -9411,7 +9495,7 @@
                 <a:solidFill>
                   <a:srgbClr val="12303D"/>
                 </a:solidFill>
-                <a:latin typeface="Arial" pitchFamily="34" charset="0"/>
+                <a:latin typeface="Nunito Sans" pitchFamily="34" charset="0"/>
                 <a:ea typeface="Arial" pitchFamily="34" charset="-122"/>
                 <a:cs typeface="Arial" pitchFamily="34" charset="-120"/>
               </a:rPr>
@@ -9455,7 +9539,7 @@
                 <a:solidFill>
                   <a:srgbClr val="B26A00"/>
                 </a:solidFill>
-                <a:latin typeface="Arial" pitchFamily="34" charset="0"/>
+                <a:latin typeface="Nunito Sans" pitchFamily="34" charset="0"/>
                 <a:ea typeface="Arial" pitchFamily="34" charset="-122"/>
                 <a:cs typeface="Arial" pitchFamily="34" charset="-120"/>
               </a:rPr>
@@ -9474,7 +9558,7 @@
         <p:spPr>
           <a:xfrm>
             <a:off x="825500" y="3467050"/>
-            <a:ext cx="10541000" cy="1004713"/>
+            <a:ext cx="10541000" cy="1101233"/>
           </a:xfrm>
           <a:prstGeom prst="roundRect">
             <a:avLst>
@@ -9530,7 +9614,7 @@
                 <a:solidFill>
                   <a:srgbClr val="12303D"/>
                 </a:solidFill>
-                <a:latin typeface="Georgia" pitchFamily="34" charset="0"/>
+                <a:latin typeface="Domine" pitchFamily="34" charset="0"/>
                 <a:ea typeface="Georgia" pitchFamily="34" charset="-122"/>
                 <a:cs typeface="Georgia" pitchFamily="34" charset="-120"/>
               </a:rPr>
@@ -9570,33 +9654,11 @@
               <a:buNone/>
             </a:pPr>
             <a:r>
-              <a:rPr lang="en-US" sz="1300" b="1" dirty="0">
+              <a:rPr lang="en-US" sz="1300" u="sng" dirty="0">
                 <a:solidFill>
                   <a:srgbClr val="12303D"/>
                 </a:solidFill>
-                <a:latin typeface="Arial" pitchFamily="34" charset="0"/>
-                <a:ea typeface="Arial" pitchFamily="34" charset="-122"/>
-                <a:cs typeface="Arial" pitchFamily="34" charset="-120"/>
-              </a:rPr>
-              <a:t>Click link to see visual representation:</a:t>
-            </a:r>
-            <a:r>
-              <a:rPr lang="en-US" sz="1300" dirty="0">
-                <a:solidFill>
-                  <a:srgbClr val="12303D"/>
-                </a:solidFill>
-                <a:latin typeface="Arial" pitchFamily="34" charset="0"/>
-                <a:ea typeface="Arial" pitchFamily="34" charset="-122"/>
-                <a:cs typeface="Arial" pitchFamily="34" charset="-120"/>
-              </a:rPr>
-              <a:t> </a:t>
-            </a:r>
-            <a:r>
-              <a:rPr lang="en-US" sz="1300" u="sng" dirty="0">
-                <a:solidFill>
-                  <a:srgbClr val="12303D"/>
-                </a:solidFill>
-                <a:latin typeface="Arial" pitchFamily="34" charset="0"/>
+                <a:latin typeface="Nunito Sans" pitchFamily="34" charset="0"/>
                 <a:ea typeface="Arial" pitchFamily="34" charset="-122"/>
                 <a:cs typeface="Arial" pitchFamily="34" charset="-120"/>
                 <a:hlinkClick r:id="rId9"/>
@@ -9641,7 +9703,7 @@
                 <a:solidFill>
                   <a:srgbClr val="12435A"/>
                 </a:solidFill>
-                <a:latin typeface="Arial" pitchFamily="34" charset="0"/>
+                <a:latin typeface="Nunito Sans" pitchFamily="34" charset="0"/>
                 <a:ea typeface="Arial" pitchFamily="34" charset="-122"/>
                 <a:cs typeface="Arial" pitchFamily="34" charset="-120"/>
               </a:rPr>
@@ -9652,7 +9714,7 @@
                 <a:solidFill>
                   <a:srgbClr val="12303D"/>
                 </a:solidFill>
-                <a:latin typeface="Arial" pitchFamily="34" charset="0"/>
+                <a:latin typeface="Nunito Sans" pitchFamily="34" charset="0"/>
                 <a:ea typeface="Arial" pitchFamily="34" charset="-122"/>
                 <a:cs typeface="Arial" pitchFamily="34" charset="-120"/>
               </a:rPr>
@@ -9663,7 +9725,7 @@
                 <a:solidFill>
                   <a:srgbClr val="4A5565"/>
                 </a:solidFill>
-                <a:latin typeface="Arial" pitchFamily="34" charset="0"/>
+                <a:latin typeface="Nunito Sans" pitchFamily="34" charset="0"/>
                 <a:ea typeface="Arial" pitchFamily="34" charset="-122"/>
                 <a:cs typeface="Arial" pitchFamily="34" charset="-120"/>
               </a:rPr>
@@ -9674,7 +9736,7 @@
                 <a:solidFill>
                   <a:srgbClr val="12303D"/>
                 </a:solidFill>
-                <a:latin typeface="Arial" pitchFamily="34" charset="0"/>
+                <a:latin typeface="Nunito Sans" pitchFamily="34" charset="0"/>
                 <a:ea typeface="Arial" pitchFamily="34" charset="-122"/>
                 <a:cs typeface="Arial" pitchFamily="34" charset="-120"/>
               </a:rPr>
@@ -9685,7 +9747,7 @@
                 <a:solidFill>
                   <a:srgbClr val="A84B25"/>
                 </a:solidFill>
-                <a:latin typeface="Arial" pitchFamily="34" charset="0"/>
+                <a:latin typeface="Nunito Sans" pitchFamily="34" charset="0"/>
                 <a:ea typeface="Arial" pitchFamily="34" charset="-122"/>
                 <a:cs typeface="Arial" pitchFamily="34" charset="-120"/>
               </a:rPr>
@@ -9696,7 +9758,7 @@
                 <a:solidFill>
                   <a:srgbClr val="12303D"/>
                 </a:solidFill>
-                <a:latin typeface="Arial" pitchFamily="34" charset="0"/>
+                <a:latin typeface="Nunito Sans" pitchFamily="34" charset="0"/>
                 <a:ea typeface="Arial" pitchFamily="34" charset="-122"/>
                 <a:cs typeface="Arial" pitchFamily="34" charset="-120"/>
               </a:rPr>
@@ -9707,7 +9769,7 @@
                 <a:solidFill>
                   <a:srgbClr val="4A5565"/>
                 </a:solidFill>
-                <a:latin typeface="Arial" pitchFamily="34" charset="0"/>
+                <a:latin typeface="Nunito Sans" pitchFamily="34" charset="0"/>
                 <a:ea typeface="Arial" pitchFamily="34" charset="-122"/>
                 <a:cs typeface="Arial" pitchFamily="34" charset="-120"/>
               </a:rPr>
@@ -9718,7 +9780,7 @@
                 <a:solidFill>
                   <a:srgbClr val="12303D"/>
                 </a:solidFill>
-                <a:latin typeface="Arial" pitchFamily="34" charset="0"/>
+                <a:latin typeface="Nunito Sans" pitchFamily="34" charset="0"/>
                 <a:ea typeface="Arial" pitchFamily="34" charset="-122"/>
                 <a:cs typeface="Arial" pitchFamily="34" charset="-120"/>
               </a:rPr>
@@ -9729,7 +9791,7 @@
                 <a:solidFill>
                   <a:srgbClr val="4F6B3A"/>
                 </a:solidFill>
-                <a:latin typeface="Arial" pitchFamily="34" charset="0"/>
+                <a:latin typeface="Nunito Sans" pitchFamily="34" charset="0"/>
                 <a:ea typeface="Arial" pitchFamily="34" charset="-122"/>
                 <a:cs typeface="Arial" pitchFamily="34" charset="-120"/>
               </a:rPr>
@@ -9740,7 +9802,7 @@
                 <a:solidFill>
                   <a:srgbClr val="12303D"/>
                 </a:solidFill>
-                <a:latin typeface="Arial" pitchFamily="34" charset="0"/>
+                <a:latin typeface="Nunito Sans" pitchFamily="34" charset="0"/>
                 <a:ea typeface="Arial" pitchFamily="34" charset="-122"/>
                 <a:cs typeface="Arial" pitchFamily="34" charset="-120"/>
               </a:rPr>
@@ -9751,7 +9813,7 @@
                 <a:solidFill>
                   <a:srgbClr val="4A5565"/>
                 </a:solidFill>
-                <a:latin typeface="Arial" pitchFamily="34" charset="0"/>
+                <a:latin typeface="Nunito Sans" pitchFamily="34" charset="0"/>
                 <a:ea typeface="Arial" pitchFamily="34" charset="-122"/>
                 <a:cs typeface="Arial" pitchFamily="34" charset="-120"/>
               </a:rPr>
@@ -9762,7 +9824,7 @@
                 <a:solidFill>
                   <a:srgbClr val="12303D"/>
                 </a:solidFill>
-                <a:latin typeface="Arial" pitchFamily="34" charset="0"/>
+                <a:latin typeface="Nunito Sans" pitchFamily="34" charset="0"/>
                 <a:ea typeface="Arial" pitchFamily="34" charset="-122"/>
                 <a:cs typeface="Arial" pitchFamily="34" charset="-120"/>
               </a:rPr>
@@ -9773,7 +9835,7 @@
                 <a:solidFill>
                   <a:srgbClr val="B26A00"/>
                 </a:solidFill>
-                <a:latin typeface="Arial" pitchFamily="34" charset="0"/>
+                <a:latin typeface="Nunito Sans" pitchFamily="34" charset="0"/>
                 <a:ea typeface="Arial" pitchFamily="34" charset="-122"/>
                 <a:cs typeface="Arial" pitchFamily="34" charset="-120"/>
               </a:rPr>

</xml_diff>

<commit_message>
Rename Area coordinator to Ward coordinator (and Partner ward coordinator) in the deck and personas page
Same authority as before: plans and schedules training for all the wards in their area.
The PDF is not yet regenerated from the updated deck.

Co-Authored-By: Claude Opus 5.5 <noreply@anthropic.com>
Claude-Session: https://claude.ai/code/session_01M56hYsaTYE5EwxLtD5GS9V
</commit_message>
<xml_diff>
--- a/CMG-Training-system-introduction.pptx
+++ b/CMG-Training-system-introduction.pptx
@@ -595,7 +595,7 @@
           <a:p>
             <a:r>
               <a:rPr lang="en-US" dirty="0"/>
-              <a:t>Start in the depot: a lesson is written, reviewed by a second author and translated, and the district officer registers the groups, before anything moves. "The coordinator" is the district coordinator, or the area coordinator where the district has been divided into areas. First stop: the partner trains its trainers, who must pass a quiz at 90 percent to be certified. Walk the line, round the bend, and back. Pause at the green band: the platform is not open during a session. The trainer carries a printed sheet, the group signs on paper, and the report is typed in afterwards.</a:t>
+              <a:t>Start in the depot: a lesson is written, reviewed by a second author and translated, and the district officer registers the groups, before anything moves. "The coordinator" is the district coordinator, or the ward coordinator where the district has been divided into areas; a ward coordinator plans and schedules for every ward in their area. First stop: the partner trains its trainers, who must pass a quiz at 90 percent to be certified. Walk the line, round the bend, and back. Pause at the green band: the platform is not open during a session. The trainer carries a printed sheet, the group signs on paper, and the report is typed in afterwards.</a:t>
             </a:r>
             <a:endParaRPr lang="en-US" dirty="0"/>
           </a:p>
@@ -771,7 +771,7 @@
           <a:p>
             <a:r>
               <a:rPr lang="en-US" dirty="0"/>
-              <a:t>TAMISEMI is the government side; the BDS partner is the delivery partner. The hierarchy is national, region, district, area, ward, village, group. "The coordinator" means the district coordinator, who runs training in a district, draws its areas and appoints their coordinators. The district officer is a separate role that keeps the register: only they add groups. The regional coordinator oversees and covers, and alone confirms postings, hands over and does spot checks. The partner has no district-level counterpart for now. Coordination moves from the left wing to the right wing on the area floor, one area at a time.</a:t>
+              <a:t>TAMISEMI is the government side; the BDS partner is the delivery partner. The hierarchy is national, region, district, area, ward, village, group. "The coordinator" means the district coordinator, who runs training in a district, draws its areas and appoints their ward coordinators, each of whom plans and schedules for several wards. The district officer is a separate role that keeps the register: only they add groups. The regional coordinator oversees and covers, and alone confirms postings, hands over and does spot checks. The partner has no district-level counterpart for now. Coordination moves from the left wing to the right wing on the area floor, one area at a time.</a:t>
             </a:r>
             <a:endParaRPr lang="en-US" dirty="0"/>
           </a:p>
@@ -5505,7 +5505,7 @@
                 <a:ea typeface="Arial" pitchFamily="34" charset="-122"/>
                 <a:cs typeface="Arial" pitchFamily="34" charset="-120"/>
               </a:rPr>
-              <a:t>Area coordinator + stand-in</a:t>
+              <a:t>Ward coordinator + stand-in</a:t>
             </a:r>
             <a:endParaRPr lang="en-US" sz="1500" dirty="0"/>
           </a:p>
@@ -5685,7 +5685,7 @@
                 <a:ea typeface="Arial" pitchFamily="34" charset="-122"/>
                 <a:cs typeface="Arial" pitchFamily="34" charset="-120"/>
               </a:rPr>
-              <a:t>Partner area coordinator</a:t>
+              <a:t>Partner ward coordinator</a:t>
             </a:r>
             <a:endParaRPr lang="en-US" sz="1500" dirty="0"/>
           </a:p>
@@ -6268,7 +6268,7 @@
                 <a:ea typeface="Arial" pitchFamily="34" charset="-122"/>
                 <a:cs typeface="Arial" pitchFamily="34" charset="-120"/>
               </a:rPr>
-              <a:t> It is a named subset of wards inside one district, which the coordinator draws and can redraw so that one person has a workable patch. Records stay by region, district and ward.</a:t>
+              <a:t> It is a named subset of wards inside one district, which the coordinator draws and can redraw so that one ward coordinator has a workable patch. Records stay by region, district and ward.</a:t>
             </a:r>
             <a:endParaRPr lang="en-US" sz="1200" dirty="0"/>
           </a:p>
@@ -7035,7 +7035,7 @@
                 <a:ea typeface="Arial" pitchFamily="34" charset="-122"/>
                 <a:cs typeface="Arial" pitchFamily="34" charset="-120"/>
               </a:rPr>
-              <a:t>Area coordinator</a:t>
+              <a:t>Ward coordinator</a:t>
             </a:r>
             <a:endParaRPr lang="en-US" sz="1200" dirty="0"/>
           </a:p>
@@ -7154,7 +7154,7 @@
                 <a:ea typeface="Arial" pitchFamily="34" charset="-122"/>
                 <a:cs typeface="Arial" pitchFamily="34" charset="-120"/>
               </a:rPr>
-              <a:t>Partner area coordinator</a:t>
+              <a:t>Partner ward coordinator</a:t>
             </a:r>
             <a:endParaRPr lang="en-US" sz="1200" dirty="0"/>
           </a:p>
@@ -7886,7 +7886,7 @@
                 <a:ea typeface="Arial" pitchFamily="34" charset="-122"/>
                 <a:cs typeface="Arial" pitchFamily="34" charset="-120"/>
               </a:rPr>
-              <a:t>Area coordinator</a:t>
+              <a:t>Ward coordinator</a:t>
             </a:r>
             <a:endParaRPr lang="en-US" sz="1200" dirty="0"/>
           </a:p>
@@ -8005,7 +8005,7 @@
                 <a:ea typeface="Arial" pitchFamily="34" charset="-122"/>
                 <a:cs typeface="Arial" pitchFamily="34" charset="-120"/>
               </a:rPr>
-              <a:t>Partner area coordinator</a:t>
+              <a:t>Partner ward coordinator</a:t>
             </a:r>
             <a:endParaRPr lang="en-US" sz="1200" dirty="0"/>
           </a:p>

</xml_diff>

<commit_message>
Update the deck and personas page for CR-16 to CR-23
- Slide 3: the district coordinator builds the plan; the ward coordinator runs it
- Slide 4: trainer manager and partner director; "Dist. coordinator"
- Slide 5: district builds plans, ward runs them, before and after a handoff
- Slide 6: nine people, with the partner director added
- personas.html: nine people (the partner manager split in two)

Co-Authored-By: Claude Opus 5.5 <noreply@anthropic.com>
Claude-Session: https://claude.ai/code/session_0143QkxvYEhUwpwGGGHTqteW
</commit_message>
<xml_diff>
--- a/CMG-Training-system-introduction.pptx
+++ b/CMG-Training-system-introduction.pptx
@@ -507,7 +507,7 @@
           <a:p>
             <a:r>
               <a:rPr lang="en-US" dirty="0"/>
-              <a:t>Slide 2 is the whole journey. Slide 3 zooms in on two of its stops, planning and scheduling. Slides 4 and 5 are the people: slide 4 shows the five levels (national, region, district, area, village) and the two sides, and explains what an area is; slide 5 shows what changes when operations are handed from TAMISEMI to the BDS partner. Updated on 21 September 2026 for the district coordinator and the district officer.</a:t>
+              <a:t>Slide 2 is the whole journey. Slide 3 zooms in on two of its stops, planning and scheduling. Slides 4 and 5 are the people: slide 4 shows the five levels (national, region, district, area, village) and the two sides, and explains what an area is; slide 5 shows what changes when operations are handed from TAMISEMI to the BDS partner. Updated on 21 September 2026 for the district coordinator and the district officer. Updated again on 25 September 2026: plans are built by the district coordinator (shown as "Dist. coordinator") and run by ward coordinators, and the partner manager is split into the trainer manager and the partner director.</a:t>
             </a:r>
             <a:endParaRPr lang="en-US" dirty="0"/>
           </a:p>
@@ -595,7 +595,7 @@
           <a:p>
             <a:r>
               <a:rPr lang="en-US" dirty="0"/>
-              <a:t>Start in the depot: a lesson is written, reviewed by a second author and translated, and the district officer registers the groups, before anything moves. "The coordinator" is the district coordinator, or the ward coordinator where the district has been divided into areas; a ward coordinator plans and schedules for every ward in their area. First stop: the partner trains its trainers, who must pass a quiz at 90 percent to be certified. Walk the line, round the bend, and back. Pause at the green band: the platform is not open during a session. The trainer carries a printed sheet, the group signs on paper, and the report is typed in afterwards.</a:t>
+              <a:t>Start in the depot: a lesson is written, reviewed by a second author and translated, and the district officer registers the groups, before anything moves. The coordinator here is the district coordinator ("Dist. coordinator" on screen), or the ward coordinator where the district has been divided into areas. First stop: the partner's trainer manager trains its trainers, who must pass a quiz at 90 percent to be certified. Walk the line, round the bend, and back. Pause at the green band: the platform is not open during a session. The trainer carries a printed sheet, the group signs on paper, and the report is typed in afterwards.</a:t>
             </a:r>
             <a:endParaRPr lang="en-US" dirty="0"/>
           </a:p>
@@ -683,7 +683,7 @@
           <a:p>
             <a:r>
               <a:rPr lang="en-US" dirty="0"/>
-              <a:t>The normal path is plan, then schedule. The planner answers a capacity question for an area over six weeks and never names a person. Assigning a trainer is what runs the rules: registered group, certified and posted trainer, one session a day, module order, the duration limit. A draft session is the exception, not a stage: it parks a visit whose trainer is not decided, and it is where a booking lands, with the reason, when a rule refuses it.</a:t>
+              <a:t>The normal path is plan, then schedule. The planner answers a capacity question for an area over six weeks and never names a person. The district coordinator builds the plan; the ward coordinator runs it week by week, creating its sessions and assigning trainers. Assigning a trainer is what runs the rules: registered group, certified and posted trainer, one session a day, module order, the duration limit. A draft session is the exception, not a stage: it parks a visit whose trainer is not decided, and it is where a booking lands, with the reason, when a rule refuses it.</a:t>
             </a:r>
             <a:endParaRPr lang="en-US" dirty="0"/>
           </a:p>
@@ -771,7 +771,7 @@
           <a:p>
             <a:r>
               <a:rPr lang="en-US" dirty="0"/>
-              <a:t>TAMISEMI is the government side; the BDS partner is the delivery partner. The hierarchy is national, region, district, area, ward, village, group. "The coordinator" means the district coordinator, who runs training in a district, draws its areas and appoints their ward coordinators, each of whom plans and schedules for several wards. The district officer is a separate role that keeps the register: only they add groups. The regional coordinator oversees and covers, and alone confirms postings, hands over and does spot checks. The partner has no district-level counterpart for now. Coordination moves from the left wing to the right wing on the area floor, one area at a time.</a:t>
+              <a:t>TAMISEMI is the government side; the BDS partner is the delivery partner. The hierarchy is national, region, district, area, ward, village, group. The district coordinator ("Dist. coordinator") builds the plans for the district, draws its areas and appoints their coordinators; ward coordinators run those plans. At the national level the partner has two people on separate logins: the trainer manager, who keeps the trainers ready, certified and posted, and the partner director, who appoints the partner's coordinators and reports delivery to the government. The district officer is a separate role that keeps the register: only they add groups. The regional coordinator oversees and covers, and alone confirms postings, hands over and does spot checks. The partner has no district-level counterpart for now. Coordination moves from the left wing to the right wing on the area floor, one area at a time.</a:t>
             </a:r>
             <a:endParaRPr lang="en-US" dirty="0"/>
           </a:p>
@@ -859,7 +859,7 @@
           <a:p>
             <a:r>
               <a:rPr lang="en-US" dirty="0"/>
-              <a:t>TAMISEMI is the government side; the BDS partner is the delivery partner. Before a handoff TAMISEMI coordinates the area and the partner supplies the trainers and watches. After it, the partner coordinates that area and TAMISEMI steps back and checks. The district coordinator is "the coordinator": they draw the areas, and carry on coordinating the parts of the district that have not been handed over. The partner has no district-level counterpart for now. Only an administrator or the regional coordinator can hand an area over, by typing its name, and only once the partner has a coordinator there. Supervision afterwards is by sampled reports and the progress page. One rule holds on both sides: nobody accepts a report for a session they delivered.</a:t>
+              <a:t>TAMISEMI is the government side; the BDS partner is the delivery partner. Before a handoff TAMISEMI coordinates the area and the partner supplies the trainers and watches. After it, the partner coordinates that area and TAMISEMI steps back and checks. The district coordinator ("Dist. coordinator") draws the areas, builds the plans, and carries on coordinating the parts of the district that have not been handed over. After a handoff the partner's regional lead builds that area's plans and the partner ward coordinator runs them. The partner has no district-level counterpart for now. Only an administrator or the regional coordinator can hand an area over, by typing its name, and only once the partner has a coordinator there. Supervision afterwards is by sampled reports and the progress page. One rule holds on both sides: nobody accepts a report for a session they delivered.</a:t>
             </a:r>
             <a:endParaRPr lang="en-US" dirty="0"/>
           </a:p>
@@ -947,7 +947,7 @@
           <a:p>
             <a:r>
               <a:rPr lang="en-US" dirty="0"/>
-              <a:t>Open the linked page and walk the line with the arrow keys, or choose a person. Start with the coordinator: the rest of the system turns round that job. Each person shows five things they do, their goal, and the success line from the personas spec. The district coordinator's success line is written from their goal, because the spec gives none yet. The page is private until it is shared, like this deck.</a:t>
+              <a:t>Open the linked page and walk the line with the arrow keys, or choose a person. Start with the Dist. coordinator: the rest of the system turns round that job. The partner manager is now two people, the trainer manager and the partner director. Each person shows five things they do, their goal, and the success line from the personas spec. The district coordinator's success line is written from their goal, because the spec gives none yet. The page is private until it is shared, like this deck.</a:t>
             </a:r>
             <a:endParaRPr lang="en-US" dirty="0"/>
           </a:p>
@@ -3390,7 +3390,7 @@
                 <a:ea typeface="Arial" pitchFamily="34" charset="-122"/>
                 <a:cs typeface="Arial" pitchFamily="34" charset="-120"/>
               </a:rPr>
-              <a:t>Does the work fit, and what are the trips?</a:t>
+              <a:t>Does the work fit, and in which week?</a:t>
             </a:r>
             <a:endParaRPr lang="en-US" sz="1500" dirty="0"/>
           </a:p>
@@ -3456,7 +3456,7 @@
                 <a:ea typeface="Arial" pitchFamily="34" charset="-122"/>
                 <a:cs typeface="Arial" pitchFamily="34" charset="-120"/>
               </a:rPr>
-              <a:t>Trainer 1, Trainer 2: Trainer n</a:t>
+              <a:t>Dist. coordinator builds it; ward coordinator runs it</a:t>
             </a:r>
             <a:endParaRPr lang="en-US" sz="1200" dirty="0"/>
           </a:p>
@@ -4524,7 +4524,7 @@
                 <a:ea typeface="Arial" pitchFamily="34" charset="-122"/>
                 <a:cs typeface="Arial" pitchFamily="34" charset="-120"/>
               </a:rPr>
-              <a:t>Partner manager</a:t>
+              <a:t>Trainer manager + director</a:t>
             </a:r>
             <a:endParaRPr lang="en-US" sz="1500" dirty="0"/>
           </a:p>
@@ -4568,7 +4568,7 @@
                 <a:ea typeface="Arial" pitchFamily="34" charset="-122"/>
                 <a:cs typeface="Arial" pitchFamily="34" charset="-120"/>
               </a:rPr>
-              <a:t>Certifies the trainers</a:t>
+              <a:t>Trainers certified · delivery reported</a:t>
             </a:r>
             <a:endParaRPr lang="en-US" sz="1200" dirty="0"/>
           </a:p>
@@ -5118,7 +5118,7 @@
                 <a:ea typeface="Arial" pitchFamily="34" charset="-122"/>
                 <a:cs typeface="Arial" pitchFamily="34" charset="-120"/>
               </a:rPr>
-              <a:t>The coordinator</a:t>
+              <a:t>Dist. coordinator</a:t>
             </a:r>
             <a:endParaRPr lang="en-US" sz="1500" dirty="0"/>
           </a:p>
@@ -5549,7 +5549,7 @@
                 <a:ea typeface="Arial" pitchFamily="34" charset="-122"/>
                 <a:cs typeface="Arial" pitchFamily="34" charset="-120"/>
               </a:rPr>
-              <a:t>Plans, schedules, accepts</a:t>
+              <a:t>Runs the plan, schedules, accepts</a:t>
             </a:r>
             <a:endParaRPr lang="en-US" sz="1200" dirty="0"/>
           </a:p>
@@ -6268,7 +6268,7 @@
                 <a:ea typeface="Arial" pitchFamily="34" charset="-122"/>
                 <a:cs typeface="Arial" pitchFamily="34" charset="-120"/>
               </a:rPr>
-              <a:t> It is a named subset of wards inside one district, which the coordinator draws and can redraw so that one ward coordinator has a workable patch. Records stay by region, district and ward.</a:t>
+              <a:t> It is a named subset of wards inside one district, which the Dist. coordinator draws and can redraw so that one person has a workable patch. Records stay by region, district and ward.</a:t>
             </a:r>
             <a:endParaRPr lang="en-US" sz="1200" dirty="0"/>
           </a:p>
@@ -6885,7 +6885,7 @@
                 <a:ea typeface="Arial" pitchFamily="34" charset="-122"/>
                 <a:cs typeface="Arial" pitchFamily="34" charset="-120"/>
               </a:rPr>
-              <a:t>runs training, draws the areas</a:t>
+              <a:t>builds plans, draws the areas</a:t>
             </a:r>
             <a:endParaRPr lang="en-US" sz="1200" dirty="0"/>
           </a:p>
@@ -7079,7 +7079,7 @@
                 <a:ea typeface="Arial" pitchFamily="34" charset="-122"/>
                 <a:cs typeface="Arial" pitchFamily="34" charset="-120"/>
               </a:rPr>
-              <a:t>plans, schedules, accepts</a:t>
+              <a:t>runs the plan, schedules, accepts</a:t>
             </a:r>
             <a:endParaRPr lang="en-US" sz="1200" dirty="0"/>
           </a:p>
@@ -7617,7 +7617,7 @@
                 <a:ea typeface="Arial" pitchFamily="34" charset="-122"/>
                 <a:cs typeface="Arial" pitchFamily="34" charset="-120"/>
               </a:rPr>
-              <a:t>posts trainers, covers</a:t>
+              <a:t>builds plans, covers</a:t>
             </a:r>
             <a:endParaRPr lang="en-US" sz="1200" dirty="0"/>
           </a:p>
@@ -8049,7 +8049,7 @@
                 <a:ea typeface="Arial" pitchFamily="34" charset="-122"/>
                 <a:cs typeface="Arial" pitchFamily="34" charset="-120"/>
               </a:rPr>
-              <a:t>plans, schedules, accepts</a:t>
+              <a:t>runs the plan, schedules, accepts</a:t>
             </a:r>
             <a:endParaRPr lang="en-US" sz="1200" dirty="0"/>
           </a:p>
@@ -8653,7 +8653,7 @@
         <p:spPr>
           <a:xfrm>
             <a:off x="1828800" y="2450455"/>
-            <a:ext cx="609600" cy="31750"/>
+            <a:ext cx="444500" cy="31750"/>
           </a:xfrm>
           <a:prstGeom prst="rect">
             <a:avLst/>
@@ -8676,7 +8676,7 @@
         </p:nvSpPr>
         <p:spPr>
           <a:xfrm>
-            <a:off x="2454275" y="2126605"/>
+            <a:off x="2289175" y="2126605"/>
             <a:ext cx="679450" cy="679450"/>
           </a:xfrm>
           <a:prstGeom prst="roundRect">
@@ -8714,7 +8714,7 @@
         </p:blipFill>
         <p:spPr>
           <a:xfrm>
-            <a:off x="2628900" y="2301230"/>
+            <a:off x="2463800" y="2301230"/>
             <a:ext cx="330200" cy="330200"/>
           </a:xfrm>
           <a:prstGeom prst="rect">
@@ -8730,8 +8730,8 @@
         </p:nvSpPr>
         <p:spPr>
           <a:xfrm>
-            <a:off x="3149600" y="2450455"/>
-            <a:ext cx="609600" cy="31750"/>
+            <a:off x="2984500" y="2450455"/>
+            <a:ext cx="444500" cy="31750"/>
           </a:xfrm>
           <a:prstGeom prst="rect">
             <a:avLst/>
@@ -8754,7 +8754,7 @@
         </p:nvSpPr>
         <p:spPr>
           <a:xfrm>
-            <a:off x="3775075" y="2126605"/>
+            <a:off x="3444875" y="2126605"/>
             <a:ext cx="679450" cy="679450"/>
           </a:xfrm>
           <a:prstGeom prst="roundRect">
@@ -8792,7 +8792,7 @@
         </p:blipFill>
         <p:spPr>
           <a:xfrm>
-            <a:off x="3949700" y="2301230"/>
+            <a:off x="3619500" y="2301230"/>
             <a:ext cx="330200" cy="330200"/>
           </a:xfrm>
           <a:prstGeom prst="rect">
@@ -8808,8 +8808,8 @@
         </p:nvSpPr>
         <p:spPr>
           <a:xfrm>
-            <a:off x="4470400" y="2450455"/>
-            <a:ext cx="609600" cy="31750"/>
+            <a:off x="4140200" y="2450455"/>
+            <a:ext cx="444500" cy="31750"/>
           </a:xfrm>
           <a:prstGeom prst="rect">
             <a:avLst/>
@@ -8832,7 +8832,7 @@
         </p:nvSpPr>
         <p:spPr>
           <a:xfrm>
-            <a:off x="5095875" y="2126605"/>
+            <a:off x="4600575" y="2126605"/>
             <a:ext cx="679450" cy="679450"/>
           </a:xfrm>
           <a:prstGeom prst="roundRect">
@@ -8855,6 +8855,37 @@
           <a:p/>
         </p:txBody>
       </p:sp>
+      <p:sp>
+        <p:nvSpPr>
+          <p:cNvPr id="42" name="Shape 90"/>
+          <p:cNvSpPr/>
+          <p:nvPr/>
+        </p:nvSpPr>
+        <p:spPr>
+          <a:xfrm>
+            <a:off x="5756275" y="2126605"/>
+            <a:ext cx="679450" cy="679450"/>
+          </a:xfrm>
+          <a:prstGeom prst="roundRect">
+            <a:avLst>
+              <a:gd name="adj" fmla="val 50000"/>
+            </a:avLst>
+          </a:prstGeom>
+          <a:solidFill>
+            <a:srgbClr val="FFFBF5"/>
+          </a:solidFill>
+          <a:ln w="31750">
+            <a:solidFill>
+              <a:srgbClr val="A84B25"/>
+            </a:solidFill>
+            <a:prstDash val="solid"/>
+          </a:ln>
+        </p:spPr>
+        <p:txBody>
+          <a:bodyPr/>
+          <a:p/>
+        </p:txBody>
+      </p:sp>
       <p:pic>
         <p:nvPicPr>
           <p:cNvPr id="15" name="Image 3" descr="GraduationCap">    </p:cNvPr>
@@ -8870,7 +8901,7 @@
         </p:blipFill>
         <p:spPr>
           <a:xfrm>
-            <a:off x="5270500" y="2301230"/>
+            <a:off x="4775200" y="2301230"/>
             <a:ext cx="330200" cy="330200"/>
           </a:xfrm>
           <a:prstGeom prst="rect">
@@ -8878,6 +8909,29 @@
           </a:prstGeom>
         </p:spPr>
       </p:pic>
+      <p:pic>
+        <p:nvPicPr>
+          <p:cNvPr id="43" name="Image 90" descr="Partner director">    </p:cNvPr>
+          <p:cNvPicPr>
+            <a:picLocks noChangeAspect="1"/>
+          </p:cNvPicPr>
+          <p:nvPr/>
+        </p:nvPicPr>
+        <p:blipFill>
+          <a:blip r:embed="rId12"/>
+          <a:srcRect l="0" r="0" t="0" b="0"/>
+          <a:stretch/>
+        </p:blipFill>
+        <p:spPr>
+          <a:xfrm>
+            <a:off x="5930900" y="2301230"/>
+            <a:ext cx="330200" cy="330200"/>
+          </a:xfrm>
+          <a:prstGeom prst="rect">
+            <a:avLst/>
+          </a:prstGeom>
+        </p:spPr>
+      </p:pic>
       <p:sp>
         <p:nvSpPr>
           <p:cNvPr id="16" name="Shape 10"/>
@@ -8886,8 +8940,8 @@
         </p:nvSpPr>
         <p:spPr>
           <a:xfrm>
-            <a:off x="5791200" y="2450455"/>
-            <a:ext cx="609600" cy="31750"/>
+            <a:off x="5295900" y="2450455"/>
+            <a:ext cx="444500" cy="31750"/>
           </a:xfrm>
           <a:prstGeom prst="rect">
             <a:avLst/>
@@ -8904,13 +8958,37 @@
       </p:sp>
       <p:sp>
         <p:nvSpPr>
+          <p:cNvPr id="44" name="Shape 91"/>
+          <p:cNvSpPr/>
+          <p:nvPr/>
+        </p:nvSpPr>
+        <p:spPr>
+          <a:xfrm>
+            <a:off x="6451600" y="2450455"/>
+            <a:ext cx="444500" cy="31750"/>
+          </a:xfrm>
+          <a:prstGeom prst="rect">
+            <a:avLst/>
+          </a:prstGeom>
+          <a:solidFill>
+            <a:srgbClr val="D9CDB8"/>
+          </a:solidFill>
+          <a:ln/>
+        </p:spPr>
+        <p:txBody>
+          <a:bodyPr/>
+          <a:p/>
+        </p:txBody>
+      </p:sp>
+      <p:sp>
+        <p:nvSpPr>
           <p:cNvPr id="17" name="Shape 11"/>
           <p:cNvSpPr/>
           <p:nvPr/>
         </p:nvSpPr>
         <p:spPr>
           <a:xfrm>
-            <a:off x="6416675" y="2126605"/>
+            <a:off x="6911975" y="2126605"/>
             <a:ext cx="679450" cy="679450"/>
           </a:xfrm>
           <a:prstGeom prst="roundRect">
@@ -8955,7 +9033,7 @@
         </p:blipFill>
         <p:spPr>
           <a:xfrm>
-            <a:off x="6591300" y="2301230"/>
+            <a:off x="7086600" y="2301230"/>
             <a:ext cx="330200" cy="330200"/>
           </a:xfrm>
           <a:prstGeom prst="rect">
@@ -8971,8 +9049,8 @@
         </p:nvSpPr>
         <p:spPr>
           <a:xfrm>
-            <a:off x="7112000" y="2450455"/>
-            <a:ext cx="609600" cy="31750"/>
+            <a:off x="7607300" y="2450455"/>
+            <a:ext cx="444500" cy="31750"/>
           </a:xfrm>
           <a:prstGeom prst="rect">
             <a:avLst/>
@@ -8995,7 +9073,7 @@
         </p:nvSpPr>
         <p:spPr>
           <a:xfrm>
-            <a:off x="7737475" y="2126605"/>
+            <a:off x="8067675" y="2126605"/>
             <a:ext cx="679450" cy="679450"/>
           </a:xfrm>
           <a:prstGeom prst="roundRect">
@@ -9033,7 +9111,7 @@
         </p:blipFill>
         <p:spPr>
           <a:xfrm>
-            <a:off x="7912100" y="2301230"/>
+            <a:off x="8242300" y="2301230"/>
             <a:ext cx="330200" cy="330200"/>
           </a:xfrm>
           <a:prstGeom prst="rect">
@@ -9049,8 +9127,8 @@
         </p:nvSpPr>
         <p:spPr>
           <a:xfrm>
-            <a:off x="8432800" y="2450455"/>
-            <a:ext cx="609600" cy="31750"/>
+            <a:off x="8763000" y="2450455"/>
+            <a:ext cx="444500" cy="31750"/>
           </a:xfrm>
           <a:prstGeom prst="rect">
             <a:avLst/>
@@ -9073,7 +9151,7 @@
         </p:nvSpPr>
         <p:spPr>
           <a:xfrm>
-            <a:off x="9058275" y="2126605"/>
+            <a:off x="9223375" y="2126605"/>
             <a:ext cx="679450" cy="679450"/>
           </a:xfrm>
           <a:prstGeom prst="roundRect">
@@ -9111,7 +9189,7 @@
         </p:blipFill>
         <p:spPr>
           <a:xfrm>
-            <a:off x="9232900" y="2301230"/>
+            <a:off x="9398000" y="2301230"/>
             <a:ext cx="330200" cy="330200"/>
           </a:xfrm>
           <a:prstGeom prst="rect">
@@ -9127,8 +9205,8 @@
         </p:nvSpPr>
         <p:spPr>
           <a:xfrm>
-            <a:off x="9753600" y="2450455"/>
-            <a:ext cx="609600" cy="31750"/>
+            <a:off x="9918700" y="2450455"/>
+            <a:ext cx="444500" cy="31750"/>
           </a:xfrm>
           <a:prstGeom prst="rect">
             <a:avLst/>
@@ -9205,8 +9283,8 @@
         </p:nvSpPr>
         <p:spPr>
           <a:xfrm>
-            <a:off x="787400" y="2910830"/>
-            <a:ext cx="1371600" cy="391120"/>
+            <a:off x="895350" y="2910830"/>
+            <a:ext cx="1155700" cy="391120"/>
           </a:xfrm>
           <a:prstGeom prst="rect">
             <a:avLst/>
@@ -9227,7 +9305,7 @@
               <a:buNone/>
             </a:pPr>
             <a:r>
-              <a:rPr lang="en-US" sz="1200" b="1" dirty="0">
+              <a:rPr lang="en-US" sz="1100" b="1" dirty="0">
                 <a:solidFill>
                   <a:srgbClr val="12303D"/>
                 </a:solidFill>
@@ -9237,7 +9315,7 @@
               </a:rPr>
               <a:t>Administrator</a:t>
             </a:r>
-            <a:endParaRPr lang="en-US" sz="1200" dirty="0"/>
+            <a:endParaRPr lang="en-US" sz="1100" dirty="0"/>
           </a:p>
         </p:txBody>
       </p:sp>
@@ -9249,8 +9327,8 @@
         </p:nvSpPr>
         <p:spPr>
           <a:xfrm>
-            <a:off x="2108200" y="2910830"/>
-            <a:ext cx="1371600" cy="391120"/>
+            <a:off x="2051050" y="2910830"/>
+            <a:ext cx="1155700" cy="391120"/>
           </a:xfrm>
           <a:prstGeom prst="rect">
             <a:avLst/>
@@ -9271,7 +9349,7 @@
               <a:buNone/>
             </a:pPr>
             <a:r>
-              <a:rPr lang="en-US" sz="1200" b="1" dirty="0">
+              <a:rPr lang="en-US" sz="1100" b="1" dirty="0">
                 <a:solidFill>
                   <a:srgbClr val="12303D"/>
                 </a:solidFill>
@@ -9281,7 +9359,7 @@
               </a:rPr>
               <a:t>Content author</a:t>
             </a:r>
-            <a:endParaRPr lang="en-US" sz="1200" dirty="0"/>
+            <a:endParaRPr lang="en-US" sz="1100" dirty="0"/>
           </a:p>
         </p:txBody>
       </p:sp>
@@ -9293,8 +9371,8 @@
         </p:nvSpPr>
         <p:spPr>
           <a:xfrm>
-            <a:off x="3429000" y="2910830"/>
-            <a:ext cx="1371600" cy="391120"/>
+            <a:off x="3206750" y="2910830"/>
+            <a:ext cx="1155700" cy="391120"/>
           </a:xfrm>
           <a:prstGeom prst="rect">
             <a:avLst/>
@@ -9315,7 +9393,7 @@
               <a:buNone/>
             </a:pPr>
             <a:r>
-              <a:rPr lang="en-US" sz="1200" b="1" dirty="0">
+              <a:rPr lang="en-US" sz="1100" b="1" dirty="0">
                 <a:solidFill>
                   <a:srgbClr val="12303D"/>
                 </a:solidFill>
@@ -9325,7 +9403,7 @@
               </a:rPr>
               <a:t>District officer</a:t>
             </a:r>
-            <a:endParaRPr lang="en-US" sz="1200" dirty="0"/>
+            <a:endParaRPr lang="en-US" sz="1100" dirty="0"/>
           </a:p>
         </p:txBody>
       </p:sp>
@@ -9337,8 +9415,8 @@
         </p:nvSpPr>
         <p:spPr>
           <a:xfrm>
-            <a:off x="4749800" y="2910830"/>
-            <a:ext cx="1371600" cy="391120"/>
+            <a:off x="4362450" y="2910830"/>
+            <a:ext cx="1155700" cy="391120"/>
           </a:xfrm>
           <a:prstGeom prst="rect">
             <a:avLst/>
@@ -9359,7 +9437,7 @@
               <a:buNone/>
             </a:pPr>
             <a:r>
-              <a:rPr lang="en-US" sz="1200" b="1" dirty="0">
+              <a:rPr lang="en-US" sz="1100" b="1" dirty="0">
                 <a:solidFill>
                   <a:srgbClr val="A84B25"/>
                 </a:solidFill>
@@ -9367,9 +9445,53 @@
                 <a:ea typeface="Arial" pitchFamily="34" charset="-122"/>
                 <a:cs typeface="Arial" pitchFamily="34" charset="-120"/>
               </a:rPr>
-              <a:t>Partner manager</a:t>
-            </a:r>
-            <a:endParaRPr lang="en-US" sz="1200" dirty="0"/>
+              <a:t>Trainer manager</a:t>
+            </a:r>
+            <a:endParaRPr lang="en-US" sz="1100" dirty="0"/>
+          </a:p>
+        </p:txBody>
+      </p:sp>
+      <p:sp>
+        <p:nvSpPr>
+          <p:cNvPr id="45" name="Text 90"/>
+          <p:cNvSpPr/>
+          <p:nvPr/>
+        </p:nvSpPr>
+        <p:spPr>
+          <a:xfrm>
+            <a:off x="5518150" y="2910830"/>
+            <a:ext cx="1155700" cy="391120"/>
+          </a:xfrm>
+          <a:prstGeom prst="rect">
+            <a:avLst/>
+          </a:prstGeom>
+          <a:noFill/>
+          <a:ln/>
+        </p:spPr>
+        <p:txBody>
+          <a:bodyPr wrap="square" lIns="0" tIns="0" rIns="0" bIns="0" rtlCol="0" anchor="t">
+            <a:normAutofit/>
+          </a:bodyPr>
+          <a:lstStyle/>
+          <a:p>
+            <a:pPr algn="ctr" indent="0" marL="0">
+              <a:lnSpc>
+                <a:spcPts val="1440"/>
+              </a:lnSpc>
+              <a:buNone/>
+            </a:pPr>
+            <a:r>
+              <a:rPr lang="en-US" sz="1100" b="1" dirty="0">
+                <a:solidFill>
+                  <a:srgbClr val="A84B25"/>
+                </a:solidFill>
+                <a:latin typeface="Nunito Sans" pitchFamily="34" charset="0"/>
+                <a:ea typeface="Arial" pitchFamily="34" charset="-122"/>
+                <a:cs typeface="Arial" pitchFamily="34" charset="-120"/>
+              </a:rPr>
+              <a:t>Partner director</a:t>
+            </a:r>
+            <a:endParaRPr lang="en-US" sz="1100" dirty="0"/>
           </a:p>
         </p:txBody>
       </p:sp>
@@ -9381,8 +9503,8 @@
         </p:nvSpPr>
         <p:spPr>
           <a:xfrm>
-            <a:off x="6070600" y="2910830"/>
-            <a:ext cx="1371600" cy="391120"/>
+            <a:off x="6673850" y="2910830"/>
+            <a:ext cx="1155700" cy="391120"/>
           </a:xfrm>
           <a:prstGeom prst="rect">
             <a:avLst/>
@@ -9403,7 +9525,7 @@
               <a:buNone/>
             </a:pPr>
             <a:r>
-              <a:rPr lang="en-US" sz="1200" b="1" dirty="0">
+              <a:rPr lang="en-US" sz="1100" b="1" dirty="0">
                 <a:solidFill>
                   <a:srgbClr val="12435A"/>
                 </a:solidFill>
@@ -9411,9 +9533,9 @@
                 <a:ea typeface="Arial" pitchFamily="34" charset="-122"/>
                 <a:cs typeface="Arial" pitchFamily="34" charset="-120"/>
               </a:rPr>
-              <a:t>The coordinator</a:t>
-            </a:r>
-            <a:endParaRPr lang="en-US" sz="1200" dirty="0"/>
+              <a:t>Dist. coordinator</a:t>
+            </a:r>
+            <a:endParaRPr lang="en-US" sz="1100" dirty="0"/>
           </a:p>
         </p:txBody>
       </p:sp>
@@ -9425,8 +9547,8 @@
         </p:nvSpPr>
         <p:spPr>
           <a:xfrm>
-            <a:off x="7391400" y="2910830"/>
-            <a:ext cx="1371600" cy="391120"/>
+            <a:off x="7829550" y="2910830"/>
+            <a:ext cx="1155700" cy="391120"/>
           </a:xfrm>
           <a:prstGeom prst="rect">
             <a:avLst/>
@@ -9447,7 +9569,7 @@
               <a:buNone/>
             </a:pPr>
             <a:r>
-              <a:rPr lang="en-US" sz="1200" b="1" dirty="0">
+              <a:rPr lang="en-US" sz="1100" b="1" dirty="0">
                 <a:solidFill>
                   <a:srgbClr val="4F6B3A"/>
                 </a:solidFill>
@@ -9457,7 +9579,7 @@
               </a:rPr>
               <a:t>Trainer</a:t>
             </a:r>
-            <a:endParaRPr lang="en-US" sz="1200" dirty="0"/>
+            <a:endParaRPr lang="en-US" sz="1100" dirty="0"/>
           </a:p>
         </p:txBody>
       </p:sp>
@@ -9469,8 +9591,8 @@
         </p:nvSpPr>
         <p:spPr>
           <a:xfrm>
-            <a:off x="8712200" y="2910830"/>
-            <a:ext cx="1371600" cy="391120"/>
+            <a:off x="8985250" y="2910830"/>
+            <a:ext cx="1155700" cy="391120"/>
           </a:xfrm>
           <a:prstGeom prst="rect">
             <a:avLst/>
@@ -9491,7 +9613,7 @@
               <a:buNone/>
             </a:pPr>
             <a:r>
-              <a:rPr lang="en-US" sz="1200" b="1" dirty="0">
+              <a:rPr lang="en-US" sz="1100" b="1" dirty="0">
                 <a:solidFill>
                   <a:srgbClr val="12303D"/>
                 </a:solidFill>
@@ -9501,7 +9623,7 @@
               </a:rPr>
               <a:t>Regional coordinator</a:t>
             </a:r>
-            <a:endParaRPr lang="en-US" sz="1200" dirty="0"/>
+            <a:endParaRPr lang="en-US" sz="1100" dirty="0"/>
           </a:p>
         </p:txBody>
       </p:sp>
@@ -9513,8 +9635,8 @@
         </p:nvSpPr>
         <p:spPr>
           <a:xfrm>
-            <a:off x="10033000" y="2910830"/>
-            <a:ext cx="1371600" cy="391120"/>
+            <a:off x="10140950" y="2910830"/>
+            <a:ext cx="1155700" cy="391120"/>
           </a:xfrm>
           <a:prstGeom prst="rect">
             <a:avLst/>
@@ -9535,7 +9657,7 @@
               <a:buNone/>
             </a:pPr>
             <a:r>
-              <a:rPr lang="en-US" sz="1200" b="1" dirty="0">
+              <a:rPr lang="en-US" sz="1100" b="1" dirty="0">
                 <a:solidFill>
                   <a:srgbClr val="B26A00"/>
                 </a:solidFill>
@@ -9545,7 +9667,7 @@
               </a:rPr>
               <a:t>M&amp;E officer</a:t>
             </a:r>
-            <a:endParaRPr lang="en-US" sz="1200" dirty="0"/>
+            <a:endParaRPr lang="en-US" sz="1100" dirty="0"/>
           </a:p>
         </p:txBody>
       </p:sp>

</xml_diff>